<commit_message>
Erweitere Workshop-Deck: Teammitglieder, Agenda, Termin KW42/43
- Slide 1: Termin KW 42/43 (Okt 2026) ergaenzt
- Slide 2: alle Teammitglieder je Team mit Leitung
- Slide 3: Ganztags-Agenda (Vormittag Miteinander / Nachmittag Scope)
  mit Zeitplan; Termin KW 42/43 = 12.-25. Oktober 2026

Co-Authored-By: Claude Opus 4.8 <noreply@anthropic.com>
Claude-Session: https://claude.ai/code/session_01HefpCknsZ9fVeMqj75mAqW
</commit_message>
<xml_diff>
--- a/2026_07_08_Workshop_Digital_Workplace_Support.pptx
+++ b/2026_07_08_Workshop_Digital_Workplace_Support.pptx
@@ -6,6 +6,8 @@
   </p:sldMasterIdLst>
   <p:sldIdLst>
     <p:sldId id="256" r:id="rId7"/>
+    <p:sldId id="257" r:id="rId8"/>
+    <p:sldId id="258" r:id="rId9"/>
   </p:sldIdLst>
   <p:sldSz cx="12192000" cy="6858000" type="screen4x3"/>
   <p:notesSz cx="6858000" cy="9144000"/>
@@ -3313,8 +3315,8 @@
         </p:nvSpPr>
         <p:spPr>
           <a:xfrm>
-            <a:off x="9144000" y="320040"/>
-            <a:ext cx="2514600" cy="609600"/>
+            <a:off x="8534400" y="228600"/>
+            <a:ext cx="3124200" cy="838200"/>
           </a:xfrm>
           <a:prstGeom prst="rect">
             <a:avLst/>
@@ -3332,7 +3334,7 @@
           <a:p>
             <a:pPr algn="r"/>
             <a:r>
-              <a:rPr sz="900" b="0" i="0">
+              <a:rPr sz="850" b="0" i="0">
                 <a:solidFill>
                   <a:srgbClr val="B9C6DB"/>
                 </a:solidFill>
@@ -3351,6 +3353,18 @@
                 <a:latin typeface="Calibri"/>
               </a:rPr>
               <a:t>Alexander Passaro</a:t>
+            </a:r>
+          </a:p>
+          <a:p>
+            <a:pPr algn="r"/>
+            <a:r>
+              <a:rPr sz="950" b="1" i="0">
+                <a:solidFill>
+                  <a:srgbClr val="E0600C"/>
+                </a:solidFill>
+                <a:latin typeface="Calibri"/>
+              </a:rPr>
+              <a:t>Termin: KW 42 / 43 · Okt 2026</a:t>
             </a:r>
           </a:p>
         </p:txBody>
@@ -5255,6 +5269,3023 @@
                 <a:latin typeface="Calibri"/>
               </a:rPr>
               <a:t>Team-Charter &amp; Spielregeln  ·  Scope-Landkarte (in/out + Schnittstellen)  ·  konkrete Commitments  ·  Follow-up-Termin</a:t>
+            </a:r>
+          </a:p>
+        </p:txBody>
+      </p:sp>
+    </p:spTree>
+  </p:cSld>
+  <p:clrMapOvr>
+    <a:masterClrMapping/>
+  </p:clrMapOvr>
+</p:sld>
+</file>
+
+<file path=ppt/slides/slide2.xml><?xml version="1.0" encoding="utf-8"?>
+<p:sld xmlns:a="http://schemas.openxmlformats.org/drawingml/2006/main" xmlns:p="http://schemas.openxmlformats.org/presentationml/2006/main" xmlns:r="http://schemas.openxmlformats.org/officeDocument/2006/relationships">
+  <p:cSld>
+    <p:spTree>
+      <p:nvGrpSpPr>
+        <p:cNvPr id="1" name=""/>
+        <p:cNvGrpSpPr/>
+        <p:nvPr/>
+      </p:nvGrpSpPr>
+      <p:grpSpPr/>
+      <p:sp>
+        <p:nvSpPr>
+          <p:cNvPr id="2" name="Rectangle 1"/>
+          <p:cNvSpPr/>
+          <p:nvPr/>
+        </p:nvSpPr>
+        <p:spPr>
+          <a:xfrm>
+            <a:off x="0" y="0"/>
+            <a:ext cx="12192000" cy="6858000"/>
+          </a:xfrm>
+          <a:prstGeom prst="rect">
+            <a:avLst/>
+          </a:prstGeom>
+          <a:solidFill>
+            <a:srgbClr val="FFFFFF"/>
+          </a:solidFill>
+          <a:ln>
+            <a:noFill/>
+          </a:ln>
+          <a:effectLst/>
+        </p:spPr>
+        <p:style>
+          <a:lnRef idx="1">
+            <a:schemeClr val="accent1"/>
+          </a:lnRef>
+          <a:fillRef idx="3">
+            <a:schemeClr val="accent1"/>
+          </a:fillRef>
+          <a:effectRef idx="2">
+            <a:schemeClr val="accent1"/>
+          </a:effectRef>
+          <a:fontRef idx="minor">
+            <a:schemeClr val="lt1"/>
+          </a:fontRef>
+        </p:style>
+        <p:txBody>
+          <a:bodyPr rtlCol="0" anchor="ctr"/>
+          <a:lstStyle/>
+          <a:p>
+            <a:pPr algn="ctr"/>
+          </a:p>
+        </p:txBody>
+      </p:sp>
+      <p:sp>
+        <p:nvSpPr>
+          <p:cNvPr id="3" name="Rectangle 2"/>
+          <p:cNvSpPr/>
+          <p:nvPr/>
+        </p:nvSpPr>
+        <p:spPr>
+          <a:xfrm>
+            <a:off x="0" y="0"/>
+            <a:ext cx="12192000" cy="990600"/>
+          </a:xfrm>
+          <a:prstGeom prst="rect">
+            <a:avLst/>
+          </a:prstGeom>
+          <a:solidFill>
+            <a:srgbClr val="1B3A6B"/>
+          </a:solidFill>
+          <a:ln>
+            <a:noFill/>
+          </a:ln>
+          <a:effectLst/>
+        </p:spPr>
+        <p:style>
+          <a:lnRef idx="1">
+            <a:schemeClr val="accent1"/>
+          </a:lnRef>
+          <a:fillRef idx="3">
+            <a:schemeClr val="accent1"/>
+          </a:fillRef>
+          <a:effectRef idx="2">
+            <a:schemeClr val="accent1"/>
+          </a:effectRef>
+          <a:fontRef idx="minor">
+            <a:schemeClr val="lt1"/>
+          </a:fontRef>
+        </p:style>
+        <p:txBody>
+          <a:bodyPr rtlCol="0" anchor="ctr"/>
+          <a:lstStyle/>
+          <a:p>
+            <a:pPr algn="ctr"/>
+          </a:p>
+        </p:txBody>
+      </p:sp>
+      <p:sp>
+        <p:nvSpPr>
+          <p:cNvPr id="4" name="Rectangle 3"/>
+          <p:cNvSpPr/>
+          <p:nvPr/>
+        </p:nvSpPr>
+        <p:spPr>
+          <a:xfrm>
+            <a:off x="0" y="0"/>
+            <a:ext cx="12192000" cy="106680"/>
+          </a:xfrm>
+          <a:prstGeom prst="rect">
+            <a:avLst/>
+          </a:prstGeom>
+          <a:solidFill>
+            <a:srgbClr val="E0600C"/>
+          </a:solidFill>
+          <a:ln>
+            <a:noFill/>
+          </a:ln>
+          <a:effectLst/>
+        </p:spPr>
+        <p:style>
+          <a:lnRef idx="1">
+            <a:schemeClr val="accent1"/>
+          </a:lnRef>
+          <a:fillRef idx="3">
+            <a:schemeClr val="accent1"/>
+          </a:fillRef>
+          <a:effectRef idx="2">
+            <a:schemeClr val="accent1"/>
+          </a:effectRef>
+          <a:fontRef idx="minor">
+            <a:schemeClr val="lt1"/>
+          </a:fontRef>
+        </p:style>
+        <p:txBody>
+          <a:bodyPr rtlCol="0" anchor="ctr"/>
+          <a:lstStyle/>
+          <a:p>
+            <a:pPr algn="ctr"/>
+          </a:p>
+        </p:txBody>
+      </p:sp>
+      <p:sp>
+        <p:nvSpPr>
+          <p:cNvPr id="5" name="TextBox 4"/>
+          <p:cNvSpPr txBox="1"/>
+          <p:nvPr/>
+        </p:nvSpPr>
+        <p:spPr>
+          <a:xfrm>
+            <a:off x="609600" y="198120"/>
+            <a:ext cx="9144000" cy="381000"/>
+          </a:xfrm>
+          <a:prstGeom prst="rect">
+            <a:avLst/>
+          </a:prstGeom>
+          <a:noFill/>
+          <a:ln>
+            <a:noFill/>
+          </a:ln>
+        </p:spPr>
+        <p:txBody>
+          <a:bodyPr wrap="square" anchor="t" lIns="40000" rIns="40000" tIns="12000" bIns="12000">
+            <a:spAutoFit/>
+          </a:bodyPr>
+          <a:lstStyle/>
+          <a:p>
+            <a:pPr algn="l"/>
+            <a:r>
+              <a:rPr sz="2200" b="1" i="0">
+                <a:solidFill>
+                  <a:srgbClr val="FFFFFF"/>
+                </a:solidFill>
+                <a:latin typeface="Calibri"/>
+              </a:rPr>
+              <a:t>Unser Team</a:t>
+            </a:r>
+          </a:p>
+        </p:txBody>
+      </p:sp>
+      <p:sp>
+        <p:nvSpPr>
+          <p:cNvPr id="6" name="TextBox 5"/>
+          <p:cNvSpPr txBox="1"/>
+          <p:nvPr/>
+        </p:nvSpPr>
+        <p:spPr>
+          <a:xfrm>
+            <a:off x="609600" y="640080"/>
+            <a:ext cx="9144000" cy="266700"/>
+          </a:xfrm>
+          <a:prstGeom prst="rect">
+            <a:avLst/>
+          </a:prstGeom>
+          <a:noFill/>
+          <a:ln>
+            <a:noFill/>
+          </a:ln>
+        </p:spPr>
+        <p:txBody>
+          <a:bodyPr wrap="square" anchor="t" lIns="40000" rIns="40000" tIns="12000" bIns="12000">
+            <a:spAutoFit/>
+          </a:bodyPr>
+          <a:lstStyle/>
+          <a:p>
+            <a:pPr algn="l"/>
+            <a:r>
+              <a:rPr sz="1200" b="0" i="1">
+                <a:solidFill>
+                  <a:srgbClr val="B9C6DB"/>
+                </a:solidFill>
+                <a:latin typeface="Calibri"/>
+              </a:rPr>
+              <a:t>Digital Workplace &amp; Support · drei Teams, eine Mannschaft</a:t>
+            </a:r>
+          </a:p>
+        </p:txBody>
+      </p:sp>
+      <p:sp>
+        <p:nvSpPr>
+          <p:cNvPr id="7" name="TextBox 6"/>
+          <p:cNvSpPr txBox="1"/>
+          <p:nvPr/>
+        </p:nvSpPr>
+        <p:spPr>
+          <a:xfrm>
+            <a:off x="8534400" y="335280"/>
+            <a:ext cx="3124200" cy="457200"/>
+          </a:xfrm>
+          <a:prstGeom prst="rect">
+            <a:avLst/>
+          </a:prstGeom>
+          <a:noFill/>
+          <a:ln>
+            <a:noFill/>
+          </a:ln>
+        </p:spPr>
+        <p:txBody>
+          <a:bodyPr wrap="square" anchor="t" lIns="40000" rIns="40000" tIns="12000" bIns="12000">
+            <a:spAutoFit/>
+          </a:bodyPr>
+          <a:lstStyle/>
+          <a:p>
+            <a:pPr algn="r"/>
+            <a:r>
+              <a:rPr sz="1000" b="1" i="0">
+                <a:solidFill>
+                  <a:srgbClr val="E0600C"/>
+                </a:solidFill>
+                <a:latin typeface="Calibri"/>
+              </a:rPr>
+              <a:t>KW 42 / 43 · Okt 2026</a:t>
+            </a:r>
+          </a:p>
+        </p:txBody>
+      </p:sp>
+      <p:sp>
+        <p:nvSpPr>
+          <p:cNvPr id="8" name="Rounded Rectangle 7"/>
+          <p:cNvSpPr/>
+          <p:nvPr/>
+        </p:nvSpPr>
+        <p:spPr>
+          <a:xfrm>
+            <a:off x="533400" y="1257300"/>
+            <a:ext cx="3604260" cy="838200"/>
+          </a:xfrm>
+          <a:prstGeom prst="roundRect">
+            <a:avLst>
+              <a:gd name="adj" fmla="val 9000"/>
+            </a:avLst>
+          </a:prstGeom>
+          <a:solidFill>
+            <a:srgbClr val="1B3A6B"/>
+          </a:solidFill>
+          <a:ln>
+            <a:noFill/>
+          </a:ln>
+          <a:effectLst/>
+        </p:spPr>
+        <p:style>
+          <a:lnRef idx="1">
+            <a:schemeClr val="accent1"/>
+          </a:lnRef>
+          <a:fillRef idx="3">
+            <a:schemeClr val="accent1"/>
+          </a:fillRef>
+          <a:effectRef idx="2">
+            <a:schemeClr val="accent1"/>
+          </a:effectRef>
+          <a:fontRef idx="minor">
+            <a:schemeClr val="lt1"/>
+          </a:fontRef>
+        </p:style>
+        <p:txBody>
+          <a:bodyPr rtlCol="0" anchor="ctr"/>
+          <a:lstStyle/>
+          <a:p>
+            <a:pPr algn="ctr"/>
+          </a:p>
+        </p:txBody>
+      </p:sp>
+      <p:sp>
+        <p:nvSpPr>
+          <p:cNvPr id="9" name="TextBox 8"/>
+          <p:cNvSpPr txBox="1"/>
+          <p:nvPr/>
+        </p:nvSpPr>
+        <p:spPr>
+          <a:xfrm>
+            <a:off x="670560" y="1310640"/>
+            <a:ext cx="3345180" cy="381000"/>
+          </a:xfrm>
+          <a:prstGeom prst="rect">
+            <a:avLst/>
+          </a:prstGeom>
+          <a:noFill/>
+          <a:ln>
+            <a:noFill/>
+          </a:ln>
+        </p:spPr>
+        <p:txBody>
+          <a:bodyPr wrap="square" anchor="t" lIns="40000" rIns="40000" tIns="12000" bIns="12000">
+            <a:spAutoFit/>
+          </a:bodyPr>
+          <a:lstStyle/>
+          <a:p>
+            <a:pPr algn="l">
+              <a:lnSpc>
+                <a:spcPct val="102000"/>
+              </a:lnSpc>
+            </a:pPr>
+            <a:r>
+              <a:rPr sz="1050" b="1" i="0">
+                <a:solidFill>
+                  <a:srgbClr val="FFFFFF"/>
+                </a:solidFill>
+                <a:latin typeface="Calibri"/>
+              </a:rPr>
+              <a:t>IT Support &amp; ITSM Platform Services</a:t>
+            </a:r>
+          </a:p>
+        </p:txBody>
+      </p:sp>
+      <p:sp>
+        <p:nvSpPr>
+          <p:cNvPr id="10" name="TextBox 9"/>
+          <p:cNvSpPr txBox="1"/>
+          <p:nvPr/>
+        </p:nvSpPr>
+        <p:spPr>
+          <a:xfrm>
+            <a:off x="670560" y="1752600"/>
+            <a:ext cx="3345180" cy="266700"/>
+          </a:xfrm>
+          <a:prstGeom prst="rect">
+            <a:avLst/>
+          </a:prstGeom>
+          <a:noFill/>
+          <a:ln>
+            <a:noFill/>
+          </a:ln>
+        </p:spPr>
+        <p:txBody>
+          <a:bodyPr wrap="square" anchor="t" lIns="40000" rIns="40000" tIns="12000" bIns="12000">
+            <a:spAutoFit/>
+          </a:bodyPr>
+          <a:lstStyle/>
+          <a:p>
+            <a:pPr algn="l"/>
+            <a:r>
+              <a:rPr sz="850" b="0" i="0">
+                <a:solidFill>
+                  <a:srgbClr val="B9C6DB"/>
+                </a:solidFill>
+                <a:latin typeface="Calibri"/>
+              </a:rPr>
+              <a:t>Leitung:  </a:t>
+            </a:r>
+            <a:r>
+              <a:rPr sz="1000" b="1" i="0">
+                <a:solidFill>
+                  <a:srgbClr val="E0600C"/>
+                </a:solidFill>
+                <a:latin typeface="Calibri"/>
+              </a:rPr>
+              <a:t>Patrick Böhme</a:t>
+            </a:r>
+          </a:p>
+        </p:txBody>
+      </p:sp>
+      <p:sp>
+        <p:nvSpPr>
+          <p:cNvPr id="11" name="Rounded Rectangle 10"/>
+          <p:cNvSpPr/>
+          <p:nvPr/>
+        </p:nvSpPr>
+        <p:spPr>
+          <a:xfrm>
+            <a:off x="533400" y="2209800"/>
+            <a:ext cx="3604260" cy="4191000"/>
+          </a:xfrm>
+          <a:prstGeom prst="roundRect">
+            <a:avLst>
+              <a:gd name="adj" fmla="val 9000"/>
+            </a:avLst>
+          </a:prstGeom>
+          <a:solidFill>
+            <a:srgbClr val="FFFFFF"/>
+          </a:solidFill>
+          <a:ln w="12700">
+            <a:solidFill>
+              <a:srgbClr val="D1D7DF"/>
+            </a:solidFill>
+          </a:ln>
+          <a:effectLst/>
+        </p:spPr>
+        <p:style>
+          <a:lnRef idx="1">
+            <a:schemeClr val="accent1"/>
+          </a:lnRef>
+          <a:fillRef idx="3">
+            <a:schemeClr val="accent1"/>
+          </a:fillRef>
+          <a:effectRef idx="2">
+            <a:schemeClr val="accent1"/>
+          </a:effectRef>
+          <a:fontRef idx="minor">
+            <a:schemeClr val="lt1"/>
+          </a:fontRef>
+        </p:style>
+        <p:txBody>
+          <a:bodyPr rtlCol="0" anchor="ctr"/>
+          <a:lstStyle/>
+          <a:p>
+            <a:pPr algn="ctr"/>
+          </a:p>
+        </p:txBody>
+      </p:sp>
+      <p:sp>
+        <p:nvSpPr>
+          <p:cNvPr id="12" name="Rectangle 11"/>
+          <p:cNvSpPr/>
+          <p:nvPr/>
+        </p:nvSpPr>
+        <p:spPr>
+          <a:xfrm>
+            <a:off x="533400" y="2209800"/>
+            <a:ext cx="3604260" cy="320040"/>
+          </a:xfrm>
+          <a:prstGeom prst="rect">
+            <a:avLst/>
+          </a:prstGeom>
+          <a:solidFill>
+            <a:srgbClr val="F4F6F9"/>
+          </a:solidFill>
+          <a:ln>
+            <a:noFill/>
+          </a:ln>
+          <a:effectLst/>
+        </p:spPr>
+        <p:style>
+          <a:lnRef idx="1">
+            <a:schemeClr val="accent1"/>
+          </a:lnRef>
+          <a:fillRef idx="3">
+            <a:schemeClr val="accent1"/>
+          </a:fillRef>
+          <a:effectRef idx="2">
+            <a:schemeClr val="accent1"/>
+          </a:effectRef>
+          <a:fontRef idx="minor">
+            <a:schemeClr val="lt1"/>
+          </a:fontRef>
+        </p:style>
+        <p:txBody>
+          <a:bodyPr rtlCol="0" anchor="ctr"/>
+          <a:lstStyle/>
+          <a:p>
+            <a:pPr algn="ctr"/>
+          </a:p>
+        </p:txBody>
+      </p:sp>
+      <p:sp>
+        <p:nvSpPr>
+          <p:cNvPr id="13" name="TextBox 12"/>
+          <p:cNvSpPr txBox="1"/>
+          <p:nvPr/>
+        </p:nvSpPr>
+        <p:spPr>
+          <a:xfrm>
+            <a:off x="670560" y="2209800"/>
+            <a:ext cx="3375660" cy="320040"/>
+          </a:xfrm>
+          <a:prstGeom prst="rect">
+            <a:avLst/>
+          </a:prstGeom>
+          <a:noFill/>
+          <a:ln>
+            <a:noFill/>
+          </a:ln>
+        </p:spPr>
+        <p:txBody>
+          <a:bodyPr wrap="square" anchor="ctr" lIns="40000" rIns="40000" tIns="12000" bIns="12000">
+            <a:spAutoFit/>
+          </a:bodyPr>
+          <a:lstStyle/>
+          <a:p>
+            <a:pPr algn="l"/>
+            <a:r>
+              <a:rPr sz="900" b="1" i="0">
+                <a:solidFill>
+                  <a:srgbClr val="4B5563"/>
+                </a:solidFill>
+                <a:latin typeface="Calibri"/>
+              </a:rPr>
+              <a:t>9 Mitglieder</a:t>
+            </a:r>
+          </a:p>
+        </p:txBody>
+      </p:sp>
+      <p:sp>
+        <p:nvSpPr>
+          <p:cNvPr id="14" name="TextBox 13"/>
+          <p:cNvSpPr txBox="1"/>
+          <p:nvPr/>
+        </p:nvSpPr>
+        <p:spPr>
+          <a:xfrm>
+            <a:off x="670560" y="2628900"/>
+            <a:ext cx="3375660" cy="3657600"/>
+          </a:xfrm>
+          <a:prstGeom prst="rect">
+            <a:avLst/>
+          </a:prstGeom>
+          <a:noFill/>
+          <a:ln>
+            <a:noFill/>
+          </a:ln>
+        </p:spPr>
+        <p:txBody>
+          <a:bodyPr wrap="square" anchor="t" lIns="40000" rIns="40000" tIns="12000" bIns="12000">
+            <a:spAutoFit/>
+          </a:bodyPr>
+          <a:lstStyle/>
+          <a:p>
+            <a:pPr algn="l">
+              <a:lnSpc>
+                <a:spcPct val="112000"/>
+              </a:lnSpc>
+              <a:spcAft>
+                <a:spcPts val="300"/>
+              </a:spcAft>
+            </a:pPr>
+            <a:r>
+              <a:rPr sz="1100" b="1" i="0">
+                <a:solidFill>
+                  <a:srgbClr val="1B3A6B"/>
+                </a:solidFill>
+                <a:latin typeface="Calibri"/>
+              </a:rPr>
+              <a:t>•  </a:t>
+            </a:r>
+            <a:r>
+              <a:rPr sz="1100" b="0" i="0">
+                <a:solidFill>
+                  <a:srgbClr val="1F2937"/>
+                </a:solidFill>
+                <a:latin typeface="Calibri"/>
+              </a:rPr>
+              <a:t>Christian Falk</a:t>
+            </a:r>
+          </a:p>
+          <a:p>
+            <a:pPr algn="l">
+              <a:lnSpc>
+                <a:spcPct val="112000"/>
+              </a:lnSpc>
+              <a:spcAft>
+                <a:spcPts val="300"/>
+              </a:spcAft>
+            </a:pPr>
+            <a:r>
+              <a:rPr sz="1100" b="1" i="0">
+                <a:solidFill>
+                  <a:srgbClr val="1B3A6B"/>
+                </a:solidFill>
+                <a:latin typeface="Calibri"/>
+              </a:rPr>
+              <a:t>•  </a:t>
+            </a:r>
+            <a:r>
+              <a:rPr sz="1100" b="0" i="0">
+                <a:solidFill>
+                  <a:srgbClr val="1F2937"/>
+                </a:solidFill>
+                <a:latin typeface="Calibri"/>
+              </a:rPr>
+              <a:t>Dieter Munk</a:t>
+            </a:r>
+          </a:p>
+          <a:p>
+            <a:pPr algn="l">
+              <a:lnSpc>
+                <a:spcPct val="112000"/>
+              </a:lnSpc>
+              <a:spcAft>
+                <a:spcPts val="300"/>
+              </a:spcAft>
+            </a:pPr>
+            <a:r>
+              <a:rPr sz="1100" b="1" i="0">
+                <a:solidFill>
+                  <a:srgbClr val="1B3A6B"/>
+                </a:solidFill>
+                <a:latin typeface="Calibri"/>
+              </a:rPr>
+              <a:t>•  </a:t>
+            </a:r>
+            <a:r>
+              <a:rPr sz="1100" b="0" i="0">
+                <a:solidFill>
+                  <a:srgbClr val="1F2937"/>
+                </a:solidFill>
+                <a:latin typeface="Calibri"/>
+              </a:rPr>
+              <a:t>Otto Sliz</a:t>
+            </a:r>
+          </a:p>
+          <a:p>
+            <a:pPr algn="l">
+              <a:lnSpc>
+                <a:spcPct val="112000"/>
+              </a:lnSpc>
+              <a:spcAft>
+                <a:spcPts val="300"/>
+              </a:spcAft>
+            </a:pPr>
+            <a:r>
+              <a:rPr sz="1100" b="1" i="0">
+                <a:solidFill>
+                  <a:srgbClr val="1B3A6B"/>
+                </a:solidFill>
+                <a:latin typeface="Calibri"/>
+              </a:rPr>
+              <a:t>•  </a:t>
+            </a:r>
+            <a:r>
+              <a:rPr sz="1100" b="0" i="0">
+                <a:solidFill>
+                  <a:srgbClr val="1F2937"/>
+                </a:solidFill>
+                <a:latin typeface="Calibri"/>
+              </a:rPr>
+              <a:t>Lea Juros</a:t>
+            </a:r>
+          </a:p>
+          <a:p>
+            <a:pPr algn="l">
+              <a:lnSpc>
+                <a:spcPct val="112000"/>
+              </a:lnSpc>
+              <a:spcAft>
+                <a:spcPts val="300"/>
+              </a:spcAft>
+            </a:pPr>
+            <a:r>
+              <a:rPr sz="1100" b="1" i="0">
+                <a:solidFill>
+                  <a:srgbClr val="1B3A6B"/>
+                </a:solidFill>
+                <a:latin typeface="Calibri"/>
+              </a:rPr>
+              <a:t>•  </a:t>
+            </a:r>
+            <a:r>
+              <a:rPr sz="1100" b="0" i="0">
+                <a:solidFill>
+                  <a:srgbClr val="1F2937"/>
+                </a:solidFill>
+                <a:latin typeface="Calibri"/>
+              </a:rPr>
+              <a:t>Cem Tatar</a:t>
+            </a:r>
+          </a:p>
+          <a:p>
+            <a:pPr algn="l">
+              <a:lnSpc>
+                <a:spcPct val="112000"/>
+              </a:lnSpc>
+              <a:spcAft>
+                <a:spcPts val="300"/>
+              </a:spcAft>
+            </a:pPr>
+            <a:r>
+              <a:rPr sz="1100" b="1" i="0">
+                <a:solidFill>
+                  <a:srgbClr val="1B3A6B"/>
+                </a:solidFill>
+                <a:latin typeface="Calibri"/>
+              </a:rPr>
+              <a:t>•  </a:t>
+            </a:r>
+            <a:r>
+              <a:rPr sz="1100" b="0" i="0">
+                <a:solidFill>
+                  <a:srgbClr val="1F2937"/>
+                </a:solidFill>
+                <a:latin typeface="Calibri"/>
+              </a:rPr>
+              <a:t>Gerd Stürner</a:t>
+            </a:r>
+          </a:p>
+          <a:p>
+            <a:pPr algn="l">
+              <a:lnSpc>
+                <a:spcPct val="112000"/>
+              </a:lnSpc>
+              <a:spcAft>
+                <a:spcPts val="300"/>
+              </a:spcAft>
+            </a:pPr>
+            <a:r>
+              <a:rPr sz="1100" b="1" i="0">
+                <a:solidFill>
+                  <a:srgbClr val="1B3A6B"/>
+                </a:solidFill>
+                <a:latin typeface="Calibri"/>
+              </a:rPr>
+              <a:t>•  </a:t>
+            </a:r>
+            <a:r>
+              <a:rPr sz="1100" b="0" i="0">
+                <a:solidFill>
+                  <a:srgbClr val="1F2937"/>
+                </a:solidFill>
+                <a:latin typeface="Calibri"/>
+              </a:rPr>
+              <a:t>Oliver Gallus</a:t>
+            </a:r>
+          </a:p>
+          <a:p>
+            <a:pPr algn="l">
+              <a:lnSpc>
+                <a:spcPct val="112000"/>
+              </a:lnSpc>
+              <a:spcAft>
+                <a:spcPts val="300"/>
+              </a:spcAft>
+            </a:pPr>
+            <a:r>
+              <a:rPr sz="1100" b="1" i="0">
+                <a:solidFill>
+                  <a:srgbClr val="1B3A6B"/>
+                </a:solidFill>
+                <a:latin typeface="Calibri"/>
+              </a:rPr>
+              <a:t>•  </a:t>
+            </a:r>
+            <a:r>
+              <a:rPr sz="1100" b="0" i="0">
+                <a:solidFill>
+                  <a:srgbClr val="1F2937"/>
+                </a:solidFill>
+                <a:latin typeface="Calibri"/>
+              </a:rPr>
+              <a:t>Jose Ricardo Bock</a:t>
+            </a:r>
+          </a:p>
+          <a:p>
+            <a:pPr algn="l">
+              <a:lnSpc>
+                <a:spcPct val="112000"/>
+              </a:lnSpc>
+              <a:spcAft>
+                <a:spcPts val="300"/>
+              </a:spcAft>
+            </a:pPr>
+            <a:r>
+              <a:rPr sz="1100" b="1" i="0">
+                <a:solidFill>
+                  <a:srgbClr val="1B3A6B"/>
+                </a:solidFill>
+                <a:latin typeface="Calibri"/>
+              </a:rPr>
+              <a:t>•  </a:t>
+            </a:r>
+            <a:r>
+              <a:rPr sz="1100" b="0" i="0">
+                <a:solidFill>
+                  <a:srgbClr val="1F2937"/>
+                </a:solidFill>
+                <a:latin typeface="Calibri"/>
+              </a:rPr>
+              <a:t>Tanja Kohler</a:t>
+            </a:r>
+          </a:p>
+        </p:txBody>
+      </p:sp>
+      <p:sp>
+        <p:nvSpPr>
+          <p:cNvPr id="15" name="Rounded Rectangle 14"/>
+          <p:cNvSpPr/>
+          <p:nvPr/>
+        </p:nvSpPr>
+        <p:spPr>
+          <a:xfrm>
+            <a:off x="4328160" y="1257300"/>
+            <a:ext cx="3604260" cy="838200"/>
+          </a:xfrm>
+          <a:prstGeom prst="roundRect">
+            <a:avLst>
+              <a:gd name="adj" fmla="val 9000"/>
+            </a:avLst>
+          </a:prstGeom>
+          <a:solidFill>
+            <a:srgbClr val="1B3A6B"/>
+          </a:solidFill>
+          <a:ln>
+            <a:noFill/>
+          </a:ln>
+          <a:effectLst/>
+        </p:spPr>
+        <p:style>
+          <a:lnRef idx="1">
+            <a:schemeClr val="accent1"/>
+          </a:lnRef>
+          <a:fillRef idx="3">
+            <a:schemeClr val="accent1"/>
+          </a:fillRef>
+          <a:effectRef idx="2">
+            <a:schemeClr val="accent1"/>
+          </a:effectRef>
+          <a:fontRef idx="minor">
+            <a:schemeClr val="lt1"/>
+          </a:fontRef>
+        </p:style>
+        <p:txBody>
+          <a:bodyPr rtlCol="0" anchor="ctr"/>
+          <a:lstStyle/>
+          <a:p>
+            <a:pPr algn="ctr"/>
+          </a:p>
+        </p:txBody>
+      </p:sp>
+      <p:sp>
+        <p:nvSpPr>
+          <p:cNvPr id="16" name="TextBox 15"/>
+          <p:cNvSpPr txBox="1"/>
+          <p:nvPr/>
+        </p:nvSpPr>
+        <p:spPr>
+          <a:xfrm>
+            <a:off x="4465320" y="1310640"/>
+            <a:ext cx="3345180" cy="381000"/>
+          </a:xfrm>
+          <a:prstGeom prst="rect">
+            <a:avLst/>
+          </a:prstGeom>
+          <a:noFill/>
+          <a:ln>
+            <a:noFill/>
+          </a:ln>
+        </p:spPr>
+        <p:txBody>
+          <a:bodyPr wrap="square" anchor="t" lIns="40000" rIns="40000" tIns="12000" bIns="12000">
+            <a:spAutoFit/>
+          </a:bodyPr>
+          <a:lstStyle/>
+          <a:p>
+            <a:pPr algn="l">
+              <a:lnSpc>
+                <a:spcPct val="102000"/>
+              </a:lnSpc>
+            </a:pPr>
+            <a:r>
+              <a:rPr sz="1050" b="1" i="0">
+                <a:solidFill>
+                  <a:srgbClr val="FFFFFF"/>
+                </a:solidFill>
+                <a:latin typeface="Calibri"/>
+              </a:rPr>
+              <a:t>Modern Workplace &amp; Experience</a:t>
+            </a:r>
+          </a:p>
+        </p:txBody>
+      </p:sp>
+      <p:sp>
+        <p:nvSpPr>
+          <p:cNvPr id="17" name="TextBox 16"/>
+          <p:cNvSpPr txBox="1"/>
+          <p:nvPr/>
+        </p:nvSpPr>
+        <p:spPr>
+          <a:xfrm>
+            <a:off x="4465320" y="1752600"/>
+            <a:ext cx="3345180" cy="266700"/>
+          </a:xfrm>
+          <a:prstGeom prst="rect">
+            <a:avLst/>
+          </a:prstGeom>
+          <a:noFill/>
+          <a:ln>
+            <a:noFill/>
+          </a:ln>
+        </p:spPr>
+        <p:txBody>
+          <a:bodyPr wrap="square" anchor="t" lIns="40000" rIns="40000" tIns="12000" bIns="12000">
+            <a:spAutoFit/>
+          </a:bodyPr>
+          <a:lstStyle/>
+          <a:p>
+            <a:pPr algn="l"/>
+            <a:r>
+              <a:rPr sz="850" b="0" i="0">
+                <a:solidFill>
+                  <a:srgbClr val="B9C6DB"/>
+                </a:solidFill>
+                <a:latin typeface="Calibri"/>
+              </a:rPr>
+              <a:t>Leitung:  </a:t>
+            </a:r>
+            <a:r>
+              <a:rPr sz="1000" b="1" i="0">
+                <a:solidFill>
+                  <a:srgbClr val="E0600C"/>
+                </a:solidFill>
+                <a:latin typeface="Calibri"/>
+              </a:rPr>
+              <a:t>Christopher Hahn</a:t>
+            </a:r>
+          </a:p>
+        </p:txBody>
+      </p:sp>
+      <p:sp>
+        <p:nvSpPr>
+          <p:cNvPr id="18" name="Rounded Rectangle 17"/>
+          <p:cNvSpPr/>
+          <p:nvPr/>
+        </p:nvSpPr>
+        <p:spPr>
+          <a:xfrm>
+            <a:off x="4328160" y="2209800"/>
+            <a:ext cx="3604260" cy="4191000"/>
+          </a:xfrm>
+          <a:prstGeom prst="roundRect">
+            <a:avLst>
+              <a:gd name="adj" fmla="val 9000"/>
+            </a:avLst>
+          </a:prstGeom>
+          <a:solidFill>
+            <a:srgbClr val="FFFFFF"/>
+          </a:solidFill>
+          <a:ln w="12700">
+            <a:solidFill>
+              <a:srgbClr val="D1D7DF"/>
+            </a:solidFill>
+          </a:ln>
+          <a:effectLst/>
+        </p:spPr>
+        <p:style>
+          <a:lnRef idx="1">
+            <a:schemeClr val="accent1"/>
+          </a:lnRef>
+          <a:fillRef idx="3">
+            <a:schemeClr val="accent1"/>
+          </a:fillRef>
+          <a:effectRef idx="2">
+            <a:schemeClr val="accent1"/>
+          </a:effectRef>
+          <a:fontRef idx="minor">
+            <a:schemeClr val="lt1"/>
+          </a:fontRef>
+        </p:style>
+        <p:txBody>
+          <a:bodyPr rtlCol="0" anchor="ctr"/>
+          <a:lstStyle/>
+          <a:p>
+            <a:pPr algn="ctr"/>
+          </a:p>
+        </p:txBody>
+      </p:sp>
+      <p:sp>
+        <p:nvSpPr>
+          <p:cNvPr id="19" name="Rectangle 18"/>
+          <p:cNvSpPr/>
+          <p:nvPr/>
+        </p:nvSpPr>
+        <p:spPr>
+          <a:xfrm>
+            <a:off x="4328160" y="2209800"/>
+            <a:ext cx="3604260" cy="320040"/>
+          </a:xfrm>
+          <a:prstGeom prst="rect">
+            <a:avLst/>
+          </a:prstGeom>
+          <a:solidFill>
+            <a:srgbClr val="F4F6F9"/>
+          </a:solidFill>
+          <a:ln>
+            <a:noFill/>
+          </a:ln>
+          <a:effectLst/>
+        </p:spPr>
+        <p:style>
+          <a:lnRef idx="1">
+            <a:schemeClr val="accent1"/>
+          </a:lnRef>
+          <a:fillRef idx="3">
+            <a:schemeClr val="accent1"/>
+          </a:fillRef>
+          <a:effectRef idx="2">
+            <a:schemeClr val="accent1"/>
+          </a:effectRef>
+          <a:fontRef idx="minor">
+            <a:schemeClr val="lt1"/>
+          </a:fontRef>
+        </p:style>
+        <p:txBody>
+          <a:bodyPr rtlCol="0" anchor="ctr"/>
+          <a:lstStyle/>
+          <a:p>
+            <a:pPr algn="ctr"/>
+          </a:p>
+        </p:txBody>
+      </p:sp>
+      <p:sp>
+        <p:nvSpPr>
+          <p:cNvPr id="20" name="TextBox 19"/>
+          <p:cNvSpPr txBox="1"/>
+          <p:nvPr/>
+        </p:nvSpPr>
+        <p:spPr>
+          <a:xfrm>
+            <a:off x="4465320" y="2209800"/>
+            <a:ext cx="3375660" cy="320040"/>
+          </a:xfrm>
+          <a:prstGeom prst="rect">
+            <a:avLst/>
+          </a:prstGeom>
+          <a:noFill/>
+          <a:ln>
+            <a:noFill/>
+          </a:ln>
+        </p:spPr>
+        <p:txBody>
+          <a:bodyPr wrap="square" anchor="ctr" lIns="40000" rIns="40000" tIns="12000" bIns="12000">
+            <a:spAutoFit/>
+          </a:bodyPr>
+          <a:lstStyle/>
+          <a:p>
+            <a:pPr algn="l"/>
+            <a:r>
+              <a:rPr sz="900" b="1" i="0">
+                <a:solidFill>
+                  <a:srgbClr val="4B5563"/>
+                </a:solidFill>
+                <a:latin typeface="Calibri"/>
+              </a:rPr>
+              <a:t>9 Mitglieder</a:t>
+            </a:r>
+          </a:p>
+        </p:txBody>
+      </p:sp>
+      <p:sp>
+        <p:nvSpPr>
+          <p:cNvPr id="21" name="TextBox 20"/>
+          <p:cNvSpPr txBox="1"/>
+          <p:nvPr/>
+        </p:nvSpPr>
+        <p:spPr>
+          <a:xfrm>
+            <a:off x="4465320" y="2628900"/>
+            <a:ext cx="3375660" cy="3657600"/>
+          </a:xfrm>
+          <a:prstGeom prst="rect">
+            <a:avLst/>
+          </a:prstGeom>
+          <a:noFill/>
+          <a:ln>
+            <a:noFill/>
+          </a:ln>
+        </p:spPr>
+        <p:txBody>
+          <a:bodyPr wrap="square" anchor="t" lIns="40000" rIns="40000" tIns="12000" bIns="12000">
+            <a:spAutoFit/>
+          </a:bodyPr>
+          <a:lstStyle/>
+          <a:p>
+            <a:pPr algn="l">
+              <a:lnSpc>
+                <a:spcPct val="112000"/>
+              </a:lnSpc>
+              <a:spcAft>
+                <a:spcPts val="300"/>
+              </a:spcAft>
+            </a:pPr>
+            <a:r>
+              <a:rPr sz="1100" b="1" i="0">
+                <a:solidFill>
+                  <a:srgbClr val="1B3A6B"/>
+                </a:solidFill>
+                <a:latin typeface="Calibri"/>
+              </a:rPr>
+              <a:t>•  </a:t>
+            </a:r>
+            <a:r>
+              <a:rPr sz="1100" b="0" i="0">
+                <a:solidFill>
+                  <a:srgbClr val="1F2937"/>
+                </a:solidFill>
+                <a:latin typeface="Calibri"/>
+              </a:rPr>
+              <a:t>Philippe Duboc</a:t>
+            </a:r>
+          </a:p>
+          <a:p>
+            <a:pPr algn="l">
+              <a:lnSpc>
+                <a:spcPct val="112000"/>
+              </a:lnSpc>
+              <a:spcAft>
+                <a:spcPts val="300"/>
+              </a:spcAft>
+            </a:pPr>
+            <a:r>
+              <a:rPr sz="1100" b="1" i="0">
+                <a:solidFill>
+                  <a:srgbClr val="1B3A6B"/>
+                </a:solidFill>
+                <a:latin typeface="Calibri"/>
+              </a:rPr>
+              <a:t>•  </a:t>
+            </a:r>
+            <a:r>
+              <a:rPr sz="1100" b="0" i="0">
+                <a:solidFill>
+                  <a:srgbClr val="1F2937"/>
+                </a:solidFill>
+                <a:latin typeface="Calibri"/>
+              </a:rPr>
+              <a:t>Sven Engel</a:t>
+            </a:r>
+          </a:p>
+          <a:p>
+            <a:pPr algn="l">
+              <a:lnSpc>
+                <a:spcPct val="112000"/>
+              </a:lnSpc>
+              <a:spcAft>
+                <a:spcPts val="300"/>
+              </a:spcAft>
+            </a:pPr>
+            <a:r>
+              <a:rPr sz="1100" b="1" i="0">
+                <a:solidFill>
+                  <a:srgbClr val="1B3A6B"/>
+                </a:solidFill>
+                <a:latin typeface="Calibri"/>
+              </a:rPr>
+              <a:t>•  </a:t>
+            </a:r>
+            <a:r>
+              <a:rPr sz="1100" b="0" i="0">
+                <a:solidFill>
+                  <a:srgbClr val="1F2937"/>
+                </a:solidFill>
+                <a:latin typeface="Calibri"/>
+              </a:rPr>
+              <a:t>Mathias Heisig</a:t>
+            </a:r>
+          </a:p>
+          <a:p>
+            <a:pPr algn="l">
+              <a:lnSpc>
+                <a:spcPct val="112000"/>
+              </a:lnSpc>
+              <a:spcAft>
+                <a:spcPts val="300"/>
+              </a:spcAft>
+            </a:pPr>
+            <a:r>
+              <a:rPr sz="1100" b="1" i="0">
+                <a:solidFill>
+                  <a:srgbClr val="1B3A6B"/>
+                </a:solidFill>
+                <a:latin typeface="Calibri"/>
+              </a:rPr>
+              <a:t>•  </a:t>
+            </a:r>
+            <a:r>
+              <a:rPr sz="1100" b="0" i="0">
+                <a:solidFill>
+                  <a:srgbClr val="1F2937"/>
+                </a:solidFill>
+                <a:latin typeface="Calibri"/>
+              </a:rPr>
+              <a:t>Thomas Bernecker</a:t>
+            </a:r>
+          </a:p>
+          <a:p>
+            <a:pPr algn="l">
+              <a:lnSpc>
+                <a:spcPct val="112000"/>
+              </a:lnSpc>
+              <a:spcAft>
+                <a:spcPts val="300"/>
+              </a:spcAft>
+            </a:pPr>
+            <a:r>
+              <a:rPr sz="1100" b="1" i="0">
+                <a:solidFill>
+                  <a:srgbClr val="1B3A6B"/>
+                </a:solidFill>
+                <a:latin typeface="Calibri"/>
+              </a:rPr>
+              <a:t>•  </a:t>
+            </a:r>
+            <a:r>
+              <a:rPr sz="1100" b="0" i="0">
+                <a:solidFill>
+                  <a:srgbClr val="1F2937"/>
+                </a:solidFill>
+                <a:latin typeface="Calibri"/>
+              </a:rPr>
+              <a:t>Dunja Akar</a:t>
+            </a:r>
+          </a:p>
+          <a:p>
+            <a:pPr algn="l">
+              <a:lnSpc>
+                <a:spcPct val="112000"/>
+              </a:lnSpc>
+              <a:spcAft>
+                <a:spcPts val="300"/>
+              </a:spcAft>
+            </a:pPr>
+            <a:r>
+              <a:rPr sz="1100" b="1" i="0">
+                <a:solidFill>
+                  <a:srgbClr val="1B3A6B"/>
+                </a:solidFill>
+                <a:latin typeface="Calibri"/>
+              </a:rPr>
+              <a:t>•  </a:t>
+            </a:r>
+            <a:r>
+              <a:rPr sz="1100" b="0" i="0">
+                <a:solidFill>
+                  <a:srgbClr val="1F2937"/>
+                </a:solidFill>
+                <a:latin typeface="Calibri"/>
+              </a:rPr>
+              <a:t>Philipp Heckhausen</a:t>
+            </a:r>
+          </a:p>
+          <a:p>
+            <a:pPr algn="l">
+              <a:lnSpc>
+                <a:spcPct val="112000"/>
+              </a:lnSpc>
+              <a:spcAft>
+                <a:spcPts val="300"/>
+              </a:spcAft>
+            </a:pPr>
+            <a:r>
+              <a:rPr sz="1100" b="1" i="0">
+                <a:solidFill>
+                  <a:srgbClr val="1B3A6B"/>
+                </a:solidFill>
+                <a:latin typeface="Calibri"/>
+              </a:rPr>
+              <a:t>•  </a:t>
+            </a:r>
+            <a:r>
+              <a:rPr sz="1100" b="0" i="0">
+                <a:solidFill>
+                  <a:srgbClr val="1F2937"/>
+                </a:solidFill>
+                <a:latin typeface="Calibri"/>
+              </a:rPr>
+              <a:t>Linda Finner</a:t>
+            </a:r>
+          </a:p>
+          <a:p>
+            <a:pPr algn="l">
+              <a:lnSpc>
+                <a:spcPct val="112000"/>
+              </a:lnSpc>
+              <a:spcAft>
+                <a:spcPts val="300"/>
+              </a:spcAft>
+            </a:pPr>
+            <a:r>
+              <a:rPr sz="1100" b="1" i="0">
+                <a:solidFill>
+                  <a:srgbClr val="1B3A6B"/>
+                </a:solidFill>
+                <a:latin typeface="Calibri"/>
+              </a:rPr>
+              <a:t>•  </a:t>
+            </a:r>
+            <a:r>
+              <a:rPr sz="1100" b="0" i="0">
+                <a:solidFill>
+                  <a:srgbClr val="1F2937"/>
+                </a:solidFill>
+                <a:latin typeface="Calibri"/>
+              </a:rPr>
+              <a:t>Sascha Kremp</a:t>
+            </a:r>
+          </a:p>
+          <a:p>
+            <a:pPr algn="l">
+              <a:lnSpc>
+                <a:spcPct val="112000"/>
+              </a:lnSpc>
+              <a:spcAft>
+                <a:spcPts val="300"/>
+              </a:spcAft>
+            </a:pPr>
+            <a:r>
+              <a:rPr sz="1100" b="1" i="0">
+                <a:solidFill>
+                  <a:srgbClr val="1B3A6B"/>
+                </a:solidFill>
+                <a:latin typeface="Calibri"/>
+              </a:rPr>
+              <a:t>•  </a:t>
+            </a:r>
+            <a:r>
+              <a:rPr sz="1100" b="0" i="0">
+                <a:solidFill>
+                  <a:srgbClr val="1F2937"/>
+                </a:solidFill>
+                <a:latin typeface="Calibri"/>
+              </a:rPr>
+              <a:t>Constanze Pretzler</a:t>
+            </a:r>
+          </a:p>
+        </p:txBody>
+      </p:sp>
+      <p:sp>
+        <p:nvSpPr>
+          <p:cNvPr id="22" name="Rounded Rectangle 21"/>
+          <p:cNvSpPr/>
+          <p:nvPr/>
+        </p:nvSpPr>
+        <p:spPr>
+          <a:xfrm>
+            <a:off x="8122920" y="1257300"/>
+            <a:ext cx="3604260" cy="838200"/>
+          </a:xfrm>
+          <a:prstGeom prst="roundRect">
+            <a:avLst>
+              <a:gd name="adj" fmla="val 9000"/>
+            </a:avLst>
+          </a:prstGeom>
+          <a:solidFill>
+            <a:srgbClr val="1B3A6B"/>
+          </a:solidFill>
+          <a:ln>
+            <a:noFill/>
+          </a:ln>
+          <a:effectLst/>
+        </p:spPr>
+        <p:style>
+          <a:lnRef idx="1">
+            <a:schemeClr val="accent1"/>
+          </a:lnRef>
+          <a:fillRef idx="3">
+            <a:schemeClr val="accent1"/>
+          </a:fillRef>
+          <a:effectRef idx="2">
+            <a:schemeClr val="accent1"/>
+          </a:effectRef>
+          <a:fontRef idx="minor">
+            <a:schemeClr val="lt1"/>
+          </a:fontRef>
+        </p:style>
+        <p:txBody>
+          <a:bodyPr rtlCol="0" anchor="ctr"/>
+          <a:lstStyle/>
+          <a:p>
+            <a:pPr algn="ctr"/>
+          </a:p>
+        </p:txBody>
+      </p:sp>
+      <p:sp>
+        <p:nvSpPr>
+          <p:cNvPr id="23" name="TextBox 22"/>
+          <p:cNvSpPr txBox="1"/>
+          <p:nvPr/>
+        </p:nvSpPr>
+        <p:spPr>
+          <a:xfrm>
+            <a:off x="8260079" y="1310640"/>
+            <a:ext cx="3345180" cy="381000"/>
+          </a:xfrm>
+          <a:prstGeom prst="rect">
+            <a:avLst/>
+          </a:prstGeom>
+          <a:noFill/>
+          <a:ln>
+            <a:noFill/>
+          </a:ln>
+        </p:spPr>
+        <p:txBody>
+          <a:bodyPr wrap="square" anchor="t" lIns="40000" rIns="40000" tIns="12000" bIns="12000">
+            <a:spAutoFit/>
+          </a:bodyPr>
+          <a:lstStyle/>
+          <a:p>
+            <a:pPr algn="l">
+              <a:lnSpc>
+                <a:spcPct val="102000"/>
+              </a:lnSpc>
+            </a:pPr>
+            <a:r>
+              <a:rPr sz="1050" b="1" i="0">
+                <a:solidFill>
+                  <a:srgbClr val="FFFFFF"/>
+                </a:solidFill>
+                <a:latin typeface="Calibri"/>
+              </a:rPr>
+              <a:t>Client Services</a:t>
+            </a:r>
+          </a:p>
+        </p:txBody>
+      </p:sp>
+      <p:sp>
+        <p:nvSpPr>
+          <p:cNvPr id="24" name="TextBox 23"/>
+          <p:cNvSpPr txBox="1"/>
+          <p:nvPr/>
+        </p:nvSpPr>
+        <p:spPr>
+          <a:xfrm>
+            <a:off x="8260079" y="1752600"/>
+            <a:ext cx="3345180" cy="266700"/>
+          </a:xfrm>
+          <a:prstGeom prst="rect">
+            <a:avLst/>
+          </a:prstGeom>
+          <a:noFill/>
+          <a:ln>
+            <a:noFill/>
+          </a:ln>
+        </p:spPr>
+        <p:txBody>
+          <a:bodyPr wrap="square" anchor="t" lIns="40000" rIns="40000" tIns="12000" bIns="12000">
+            <a:spAutoFit/>
+          </a:bodyPr>
+          <a:lstStyle/>
+          <a:p>
+            <a:pPr algn="l"/>
+            <a:r>
+              <a:rPr sz="850" b="0" i="0">
+                <a:solidFill>
+                  <a:srgbClr val="B9C6DB"/>
+                </a:solidFill>
+                <a:latin typeface="Calibri"/>
+              </a:rPr>
+              <a:t>Leitung:  </a:t>
+            </a:r>
+            <a:r>
+              <a:rPr sz="1000" b="1" i="0">
+                <a:solidFill>
+                  <a:srgbClr val="E0600C"/>
+                </a:solidFill>
+                <a:latin typeface="Calibri"/>
+              </a:rPr>
+              <a:t>Moritz Heller</a:t>
+            </a:r>
+          </a:p>
+        </p:txBody>
+      </p:sp>
+      <p:sp>
+        <p:nvSpPr>
+          <p:cNvPr id="25" name="Rounded Rectangle 24"/>
+          <p:cNvSpPr/>
+          <p:nvPr/>
+        </p:nvSpPr>
+        <p:spPr>
+          <a:xfrm>
+            <a:off x="8122920" y="2209800"/>
+            <a:ext cx="3604260" cy="4191000"/>
+          </a:xfrm>
+          <a:prstGeom prst="roundRect">
+            <a:avLst>
+              <a:gd name="adj" fmla="val 9000"/>
+            </a:avLst>
+          </a:prstGeom>
+          <a:solidFill>
+            <a:srgbClr val="FFFFFF"/>
+          </a:solidFill>
+          <a:ln w="12700">
+            <a:solidFill>
+              <a:srgbClr val="D1D7DF"/>
+            </a:solidFill>
+          </a:ln>
+          <a:effectLst/>
+        </p:spPr>
+        <p:style>
+          <a:lnRef idx="1">
+            <a:schemeClr val="accent1"/>
+          </a:lnRef>
+          <a:fillRef idx="3">
+            <a:schemeClr val="accent1"/>
+          </a:fillRef>
+          <a:effectRef idx="2">
+            <a:schemeClr val="accent1"/>
+          </a:effectRef>
+          <a:fontRef idx="minor">
+            <a:schemeClr val="lt1"/>
+          </a:fontRef>
+        </p:style>
+        <p:txBody>
+          <a:bodyPr rtlCol="0" anchor="ctr"/>
+          <a:lstStyle/>
+          <a:p>
+            <a:pPr algn="ctr"/>
+          </a:p>
+        </p:txBody>
+      </p:sp>
+      <p:sp>
+        <p:nvSpPr>
+          <p:cNvPr id="26" name="Rectangle 25"/>
+          <p:cNvSpPr/>
+          <p:nvPr/>
+        </p:nvSpPr>
+        <p:spPr>
+          <a:xfrm>
+            <a:off x="8122920" y="2209800"/>
+            <a:ext cx="3604260" cy="320040"/>
+          </a:xfrm>
+          <a:prstGeom prst="rect">
+            <a:avLst/>
+          </a:prstGeom>
+          <a:solidFill>
+            <a:srgbClr val="F4F6F9"/>
+          </a:solidFill>
+          <a:ln>
+            <a:noFill/>
+          </a:ln>
+          <a:effectLst/>
+        </p:spPr>
+        <p:style>
+          <a:lnRef idx="1">
+            <a:schemeClr val="accent1"/>
+          </a:lnRef>
+          <a:fillRef idx="3">
+            <a:schemeClr val="accent1"/>
+          </a:fillRef>
+          <a:effectRef idx="2">
+            <a:schemeClr val="accent1"/>
+          </a:effectRef>
+          <a:fontRef idx="minor">
+            <a:schemeClr val="lt1"/>
+          </a:fontRef>
+        </p:style>
+        <p:txBody>
+          <a:bodyPr rtlCol="0" anchor="ctr"/>
+          <a:lstStyle/>
+          <a:p>
+            <a:pPr algn="ctr"/>
+          </a:p>
+        </p:txBody>
+      </p:sp>
+      <p:sp>
+        <p:nvSpPr>
+          <p:cNvPr id="27" name="TextBox 26"/>
+          <p:cNvSpPr txBox="1"/>
+          <p:nvPr/>
+        </p:nvSpPr>
+        <p:spPr>
+          <a:xfrm>
+            <a:off x="8260079" y="2209800"/>
+            <a:ext cx="3375660" cy="320040"/>
+          </a:xfrm>
+          <a:prstGeom prst="rect">
+            <a:avLst/>
+          </a:prstGeom>
+          <a:noFill/>
+          <a:ln>
+            <a:noFill/>
+          </a:ln>
+        </p:spPr>
+        <p:txBody>
+          <a:bodyPr wrap="square" anchor="ctr" lIns="40000" rIns="40000" tIns="12000" bIns="12000">
+            <a:spAutoFit/>
+          </a:bodyPr>
+          <a:lstStyle/>
+          <a:p>
+            <a:pPr algn="l"/>
+            <a:r>
+              <a:rPr sz="900" b="1" i="0">
+                <a:solidFill>
+                  <a:srgbClr val="4B5563"/>
+                </a:solidFill>
+                <a:latin typeface="Calibri"/>
+              </a:rPr>
+              <a:t>5 Mitglieder</a:t>
+            </a:r>
+          </a:p>
+        </p:txBody>
+      </p:sp>
+      <p:sp>
+        <p:nvSpPr>
+          <p:cNvPr id="28" name="TextBox 27"/>
+          <p:cNvSpPr txBox="1"/>
+          <p:nvPr/>
+        </p:nvSpPr>
+        <p:spPr>
+          <a:xfrm>
+            <a:off x="8260079" y="2628900"/>
+            <a:ext cx="3375660" cy="3657600"/>
+          </a:xfrm>
+          <a:prstGeom prst="rect">
+            <a:avLst/>
+          </a:prstGeom>
+          <a:noFill/>
+          <a:ln>
+            <a:noFill/>
+          </a:ln>
+        </p:spPr>
+        <p:txBody>
+          <a:bodyPr wrap="square" anchor="t" lIns="40000" rIns="40000" tIns="12000" bIns="12000">
+            <a:spAutoFit/>
+          </a:bodyPr>
+          <a:lstStyle/>
+          <a:p>
+            <a:pPr algn="l">
+              <a:lnSpc>
+                <a:spcPct val="112000"/>
+              </a:lnSpc>
+              <a:spcAft>
+                <a:spcPts val="300"/>
+              </a:spcAft>
+            </a:pPr>
+            <a:r>
+              <a:rPr sz="1100" b="1" i="0">
+                <a:solidFill>
+                  <a:srgbClr val="1B3A6B"/>
+                </a:solidFill>
+                <a:latin typeface="Calibri"/>
+              </a:rPr>
+              <a:t>•  </a:t>
+            </a:r>
+            <a:r>
+              <a:rPr sz="1100" b="0" i="0">
+                <a:solidFill>
+                  <a:srgbClr val="1F2937"/>
+                </a:solidFill>
+                <a:latin typeface="Calibri"/>
+              </a:rPr>
+              <a:t>Pascal Mörmann</a:t>
+            </a:r>
+          </a:p>
+          <a:p>
+            <a:pPr algn="l">
+              <a:lnSpc>
+                <a:spcPct val="112000"/>
+              </a:lnSpc>
+              <a:spcAft>
+                <a:spcPts val="300"/>
+              </a:spcAft>
+            </a:pPr>
+            <a:r>
+              <a:rPr sz="1100" b="1" i="0">
+                <a:solidFill>
+                  <a:srgbClr val="1B3A6B"/>
+                </a:solidFill>
+                <a:latin typeface="Calibri"/>
+              </a:rPr>
+              <a:t>•  </a:t>
+            </a:r>
+            <a:r>
+              <a:rPr sz="1100" b="0" i="0">
+                <a:solidFill>
+                  <a:srgbClr val="1F2937"/>
+                </a:solidFill>
+                <a:latin typeface="Calibri"/>
+              </a:rPr>
+              <a:t>Edgar Sattler</a:t>
+            </a:r>
+          </a:p>
+          <a:p>
+            <a:pPr algn="l">
+              <a:lnSpc>
+                <a:spcPct val="112000"/>
+              </a:lnSpc>
+              <a:spcAft>
+                <a:spcPts val="300"/>
+              </a:spcAft>
+            </a:pPr>
+            <a:r>
+              <a:rPr sz="1100" b="1" i="0">
+                <a:solidFill>
+                  <a:srgbClr val="1B3A6B"/>
+                </a:solidFill>
+                <a:latin typeface="Calibri"/>
+              </a:rPr>
+              <a:t>•  </a:t>
+            </a:r>
+            <a:r>
+              <a:rPr sz="1100" b="0" i="0">
+                <a:solidFill>
+                  <a:srgbClr val="1F2937"/>
+                </a:solidFill>
+                <a:latin typeface="Calibri"/>
+              </a:rPr>
+              <a:t>Tim Zimmer</a:t>
+            </a:r>
+          </a:p>
+          <a:p>
+            <a:pPr algn="l">
+              <a:lnSpc>
+                <a:spcPct val="112000"/>
+              </a:lnSpc>
+              <a:spcAft>
+                <a:spcPts val="300"/>
+              </a:spcAft>
+            </a:pPr>
+            <a:r>
+              <a:rPr sz="1100" b="1" i="0">
+                <a:solidFill>
+                  <a:srgbClr val="1B3A6B"/>
+                </a:solidFill>
+                <a:latin typeface="Calibri"/>
+              </a:rPr>
+              <a:t>•  </a:t>
+            </a:r>
+            <a:r>
+              <a:rPr sz="1100" b="0" i="0">
+                <a:solidFill>
+                  <a:srgbClr val="1F2937"/>
+                </a:solidFill>
+                <a:latin typeface="Calibri"/>
+              </a:rPr>
+              <a:t>Christoph Walker</a:t>
+            </a:r>
+          </a:p>
+          <a:p>
+            <a:pPr algn="l">
+              <a:lnSpc>
+                <a:spcPct val="112000"/>
+              </a:lnSpc>
+              <a:spcAft>
+                <a:spcPts val="300"/>
+              </a:spcAft>
+            </a:pPr>
+            <a:r>
+              <a:rPr sz="1100" b="1" i="0">
+                <a:solidFill>
+                  <a:srgbClr val="1B3A6B"/>
+                </a:solidFill>
+                <a:latin typeface="Calibri"/>
+              </a:rPr>
+              <a:t>•  </a:t>
+            </a:r>
+            <a:r>
+              <a:rPr sz="1100" b="0" i="0">
+                <a:solidFill>
+                  <a:srgbClr val="1F2937"/>
+                </a:solidFill>
+                <a:latin typeface="Calibri"/>
+              </a:rPr>
+              <a:t>Magali Münzenrieder</a:t>
+            </a:r>
+          </a:p>
+        </p:txBody>
+      </p:sp>
+      <p:sp>
+        <p:nvSpPr>
+          <p:cNvPr id="29" name="TextBox 28"/>
+          <p:cNvSpPr txBox="1"/>
+          <p:nvPr/>
+        </p:nvSpPr>
+        <p:spPr>
+          <a:xfrm>
+            <a:off x="533400" y="6492240"/>
+            <a:ext cx="11125200" cy="266700"/>
+          </a:xfrm>
+          <a:prstGeom prst="rect">
+            <a:avLst/>
+          </a:prstGeom>
+          <a:noFill/>
+          <a:ln>
+            <a:noFill/>
+          </a:ln>
+        </p:spPr>
+        <p:txBody>
+          <a:bodyPr wrap="square" anchor="t" lIns="40000" rIns="40000" tIns="12000" bIns="12000">
+            <a:spAutoFit/>
+          </a:bodyPr>
+          <a:lstStyle/>
+          <a:p>
+            <a:pPr algn="l"/>
+            <a:r>
+              <a:rPr sz="850" b="0" i="1">
+                <a:solidFill>
+                  <a:srgbClr val="D1D7DF"/>
+                </a:solidFill>
+                <a:latin typeface="Calibri"/>
+              </a:rPr>
+              <a:t>Reihenfolge ohne Wertung · Stand Org-Aufstellung</a:t>
+            </a:r>
+          </a:p>
+        </p:txBody>
+      </p:sp>
+    </p:spTree>
+  </p:cSld>
+  <p:clrMapOvr>
+    <a:masterClrMapping/>
+  </p:clrMapOvr>
+</p:sld>
+</file>
+
+<file path=ppt/slides/slide3.xml><?xml version="1.0" encoding="utf-8"?>
+<p:sld xmlns:a="http://schemas.openxmlformats.org/drawingml/2006/main" xmlns:p="http://schemas.openxmlformats.org/presentationml/2006/main" xmlns:r="http://schemas.openxmlformats.org/officeDocument/2006/relationships">
+  <p:cSld>
+    <p:spTree>
+      <p:nvGrpSpPr>
+        <p:cNvPr id="1" name=""/>
+        <p:cNvGrpSpPr/>
+        <p:nvPr/>
+      </p:nvGrpSpPr>
+      <p:grpSpPr/>
+      <p:sp>
+        <p:nvSpPr>
+          <p:cNvPr id="2" name="Rectangle 1"/>
+          <p:cNvSpPr/>
+          <p:nvPr/>
+        </p:nvSpPr>
+        <p:spPr>
+          <a:xfrm>
+            <a:off x="0" y="0"/>
+            <a:ext cx="12192000" cy="6858000"/>
+          </a:xfrm>
+          <a:prstGeom prst="rect">
+            <a:avLst/>
+          </a:prstGeom>
+          <a:solidFill>
+            <a:srgbClr val="FFFFFF"/>
+          </a:solidFill>
+          <a:ln>
+            <a:noFill/>
+          </a:ln>
+          <a:effectLst/>
+        </p:spPr>
+        <p:style>
+          <a:lnRef idx="1">
+            <a:schemeClr val="accent1"/>
+          </a:lnRef>
+          <a:fillRef idx="3">
+            <a:schemeClr val="accent1"/>
+          </a:fillRef>
+          <a:effectRef idx="2">
+            <a:schemeClr val="accent1"/>
+          </a:effectRef>
+          <a:fontRef idx="minor">
+            <a:schemeClr val="lt1"/>
+          </a:fontRef>
+        </p:style>
+        <p:txBody>
+          <a:bodyPr rtlCol="0" anchor="ctr"/>
+          <a:lstStyle/>
+          <a:p>
+            <a:pPr algn="ctr"/>
+          </a:p>
+        </p:txBody>
+      </p:sp>
+      <p:sp>
+        <p:nvSpPr>
+          <p:cNvPr id="3" name="Rectangle 2"/>
+          <p:cNvSpPr/>
+          <p:nvPr/>
+        </p:nvSpPr>
+        <p:spPr>
+          <a:xfrm>
+            <a:off x="0" y="0"/>
+            <a:ext cx="12192000" cy="990600"/>
+          </a:xfrm>
+          <a:prstGeom prst="rect">
+            <a:avLst/>
+          </a:prstGeom>
+          <a:solidFill>
+            <a:srgbClr val="1B3A6B"/>
+          </a:solidFill>
+          <a:ln>
+            <a:noFill/>
+          </a:ln>
+          <a:effectLst/>
+        </p:spPr>
+        <p:style>
+          <a:lnRef idx="1">
+            <a:schemeClr val="accent1"/>
+          </a:lnRef>
+          <a:fillRef idx="3">
+            <a:schemeClr val="accent1"/>
+          </a:fillRef>
+          <a:effectRef idx="2">
+            <a:schemeClr val="accent1"/>
+          </a:effectRef>
+          <a:fontRef idx="minor">
+            <a:schemeClr val="lt1"/>
+          </a:fontRef>
+        </p:style>
+        <p:txBody>
+          <a:bodyPr rtlCol="0" anchor="ctr"/>
+          <a:lstStyle/>
+          <a:p>
+            <a:pPr algn="ctr"/>
+          </a:p>
+        </p:txBody>
+      </p:sp>
+      <p:sp>
+        <p:nvSpPr>
+          <p:cNvPr id="4" name="Rectangle 3"/>
+          <p:cNvSpPr/>
+          <p:nvPr/>
+        </p:nvSpPr>
+        <p:spPr>
+          <a:xfrm>
+            <a:off x="0" y="0"/>
+            <a:ext cx="12192000" cy="106680"/>
+          </a:xfrm>
+          <a:prstGeom prst="rect">
+            <a:avLst/>
+          </a:prstGeom>
+          <a:solidFill>
+            <a:srgbClr val="E0600C"/>
+          </a:solidFill>
+          <a:ln>
+            <a:noFill/>
+          </a:ln>
+          <a:effectLst/>
+        </p:spPr>
+        <p:style>
+          <a:lnRef idx="1">
+            <a:schemeClr val="accent1"/>
+          </a:lnRef>
+          <a:fillRef idx="3">
+            <a:schemeClr val="accent1"/>
+          </a:fillRef>
+          <a:effectRef idx="2">
+            <a:schemeClr val="accent1"/>
+          </a:effectRef>
+          <a:fontRef idx="minor">
+            <a:schemeClr val="lt1"/>
+          </a:fontRef>
+        </p:style>
+        <p:txBody>
+          <a:bodyPr rtlCol="0" anchor="ctr"/>
+          <a:lstStyle/>
+          <a:p>
+            <a:pPr algn="ctr"/>
+          </a:p>
+        </p:txBody>
+      </p:sp>
+      <p:sp>
+        <p:nvSpPr>
+          <p:cNvPr id="5" name="TextBox 4"/>
+          <p:cNvSpPr txBox="1"/>
+          <p:nvPr/>
+        </p:nvSpPr>
+        <p:spPr>
+          <a:xfrm>
+            <a:off x="609600" y="198120"/>
+            <a:ext cx="9144000" cy="381000"/>
+          </a:xfrm>
+          <a:prstGeom prst="rect">
+            <a:avLst/>
+          </a:prstGeom>
+          <a:noFill/>
+          <a:ln>
+            <a:noFill/>
+          </a:ln>
+        </p:spPr>
+        <p:txBody>
+          <a:bodyPr wrap="square" anchor="t" lIns="40000" rIns="40000" tIns="12000" bIns="12000">
+            <a:spAutoFit/>
+          </a:bodyPr>
+          <a:lstStyle/>
+          <a:p>
+            <a:pPr algn="l"/>
+            <a:r>
+              <a:rPr sz="2200" b="1" i="0">
+                <a:solidFill>
+                  <a:srgbClr val="FFFFFF"/>
+                </a:solidFill>
+                <a:latin typeface="Calibri"/>
+              </a:rPr>
+              <a:t>Workshop-Agenda</a:t>
+            </a:r>
+          </a:p>
+        </p:txBody>
+      </p:sp>
+      <p:sp>
+        <p:nvSpPr>
+          <p:cNvPr id="6" name="TextBox 5"/>
+          <p:cNvSpPr txBox="1"/>
+          <p:nvPr/>
+        </p:nvSpPr>
+        <p:spPr>
+          <a:xfrm>
+            <a:off x="609600" y="640080"/>
+            <a:ext cx="9144000" cy="266700"/>
+          </a:xfrm>
+          <a:prstGeom prst="rect">
+            <a:avLst/>
+          </a:prstGeom>
+          <a:noFill/>
+          <a:ln>
+            <a:noFill/>
+          </a:ln>
+        </p:spPr>
+        <p:txBody>
+          <a:bodyPr wrap="square" anchor="t" lIns="40000" rIns="40000" tIns="12000" bIns="12000">
+            <a:spAutoFit/>
+          </a:bodyPr>
+          <a:lstStyle/>
+          <a:p>
+            <a:pPr algn="l"/>
+            <a:r>
+              <a:rPr sz="1200" b="0" i="1">
+                <a:solidFill>
+                  <a:srgbClr val="B9C6DB"/>
+                </a:solidFill>
+                <a:latin typeface="Calibri"/>
+              </a:rPr>
+              <a:t>Team-Building &amp; Scope · Vorschlag für einen gemeinsamen Tag</a:t>
+            </a:r>
+          </a:p>
+        </p:txBody>
+      </p:sp>
+      <p:sp>
+        <p:nvSpPr>
+          <p:cNvPr id="7" name="Rounded Rectangle 6"/>
+          <p:cNvSpPr/>
+          <p:nvPr/>
+        </p:nvSpPr>
+        <p:spPr>
+          <a:xfrm>
+            <a:off x="533400" y="1181100"/>
+            <a:ext cx="11125200" cy="495300"/>
+          </a:xfrm>
+          <a:prstGeom prst="roundRect">
+            <a:avLst>
+              <a:gd name="adj" fmla="val 9000"/>
+            </a:avLst>
+          </a:prstGeom>
+          <a:solidFill>
+            <a:srgbClr val="F4F6F9"/>
+          </a:solidFill>
+          <a:ln w="9525">
+            <a:solidFill>
+              <a:srgbClr val="D1D7DF"/>
+            </a:solidFill>
+          </a:ln>
+          <a:effectLst/>
+        </p:spPr>
+        <p:style>
+          <a:lnRef idx="1">
+            <a:schemeClr val="accent1"/>
+          </a:lnRef>
+          <a:fillRef idx="3">
+            <a:schemeClr val="accent1"/>
+          </a:fillRef>
+          <a:effectRef idx="2">
+            <a:schemeClr val="accent1"/>
+          </a:effectRef>
+          <a:fontRef idx="minor">
+            <a:schemeClr val="lt1"/>
+          </a:fontRef>
+        </p:style>
+        <p:txBody>
+          <a:bodyPr rtlCol="0" anchor="ctr"/>
+          <a:lstStyle/>
+          <a:p>
+            <a:pPr algn="ctr"/>
+          </a:p>
+        </p:txBody>
+      </p:sp>
+      <p:sp>
+        <p:nvSpPr>
+          <p:cNvPr id="8" name="Rectangle 7"/>
+          <p:cNvSpPr/>
+          <p:nvPr/>
+        </p:nvSpPr>
+        <p:spPr>
+          <a:xfrm>
+            <a:off x="533400" y="1181100"/>
+            <a:ext cx="76200" cy="495300"/>
+          </a:xfrm>
+          <a:prstGeom prst="rect">
+            <a:avLst/>
+          </a:prstGeom>
+          <a:solidFill>
+            <a:srgbClr val="E0600C"/>
+          </a:solidFill>
+          <a:ln>
+            <a:noFill/>
+          </a:ln>
+          <a:effectLst/>
+        </p:spPr>
+        <p:style>
+          <a:lnRef idx="1">
+            <a:schemeClr val="accent1"/>
+          </a:lnRef>
+          <a:fillRef idx="3">
+            <a:schemeClr val="accent1"/>
+          </a:fillRef>
+          <a:effectRef idx="2">
+            <a:schemeClr val="accent1"/>
+          </a:effectRef>
+          <a:fontRef idx="minor">
+            <a:schemeClr val="lt1"/>
+          </a:fontRef>
+        </p:style>
+        <p:txBody>
+          <a:bodyPr rtlCol="0" anchor="ctr"/>
+          <a:lstStyle/>
+          <a:p>
+            <a:pPr algn="ctr"/>
+          </a:p>
+        </p:txBody>
+      </p:sp>
+      <p:sp>
+        <p:nvSpPr>
+          <p:cNvPr id="9" name="TextBox 8"/>
+          <p:cNvSpPr txBox="1"/>
+          <p:nvPr/>
+        </p:nvSpPr>
+        <p:spPr>
+          <a:xfrm>
+            <a:off x="723900" y="1181100"/>
+            <a:ext cx="10896600" cy="495300"/>
+          </a:xfrm>
+          <a:prstGeom prst="rect">
+            <a:avLst/>
+          </a:prstGeom>
+          <a:noFill/>
+          <a:ln>
+            <a:noFill/>
+          </a:ln>
+        </p:spPr>
+        <p:txBody>
+          <a:bodyPr wrap="square" anchor="ctr" lIns="40000" rIns="40000" tIns="12000" bIns="12000">
+            <a:spAutoFit/>
+          </a:bodyPr>
+          <a:lstStyle/>
+          <a:p>
+            <a:pPr algn="l"/>
+            <a:r>
+              <a:rPr sz="1150" b="1" i="0">
+                <a:solidFill>
+                  <a:srgbClr val="1B3A6B"/>
+                </a:solidFill>
+                <a:latin typeface="Calibri"/>
+              </a:rPr>
+              <a:t>Termin:  </a:t>
+            </a:r>
+            <a:r>
+              <a:rPr sz="1150" b="1" i="0">
+                <a:solidFill>
+                  <a:srgbClr val="1F2937"/>
+                </a:solidFill>
+                <a:latin typeface="Calibri"/>
+              </a:rPr>
+              <a:t>KW 42 / 43  ·  12.–25. Oktober 2026</a:t>
+            </a:r>
+            <a:r>
+              <a:rPr sz="1050" b="0" i="0">
+                <a:solidFill>
+                  <a:srgbClr val="4B5563"/>
+                </a:solidFill>
+                <a:latin typeface="Calibri"/>
+              </a:rPr>
+              <a:t>     Empfehlung: 1 gemeinsamer Tag, ca. 09:00–17:00, extern/offsite</a:t>
+            </a:r>
+          </a:p>
+        </p:txBody>
+      </p:sp>
+      <p:sp>
+        <p:nvSpPr>
+          <p:cNvPr id="10" name="Rounded Rectangle 9"/>
+          <p:cNvSpPr/>
+          <p:nvPr/>
+        </p:nvSpPr>
+        <p:spPr>
+          <a:xfrm>
+            <a:off x="533400" y="1828800"/>
+            <a:ext cx="5486400" cy="4495800"/>
+          </a:xfrm>
+          <a:prstGeom prst="roundRect">
+            <a:avLst>
+              <a:gd name="adj" fmla="val 9000"/>
+            </a:avLst>
+          </a:prstGeom>
+          <a:solidFill>
+            <a:srgbClr val="FFFFFF"/>
+          </a:solidFill>
+          <a:ln w="12700">
+            <a:solidFill>
+              <a:srgbClr val="D1D7DF"/>
+            </a:solidFill>
+          </a:ln>
+          <a:effectLst/>
+        </p:spPr>
+        <p:style>
+          <a:lnRef idx="1">
+            <a:schemeClr val="accent1"/>
+          </a:lnRef>
+          <a:fillRef idx="3">
+            <a:schemeClr val="accent1"/>
+          </a:fillRef>
+          <a:effectRef idx="2">
+            <a:schemeClr val="accent1"/>
+          </a:effectRef>
+          <a:fontRef idx="minor">
+            <a:schemeClr val="lt1"/>
+          </a:fontRef>
+        </p:style>
+        <p:txBody>
+          <a:bodyPr rtlCol="0" anchor="ctr"/>
+          <a:lstStyle/>
+          <a:p>
+            <a:pPr algn="ctr"/>
+          </a:p>
+        </p:txBody>
+      </p:sp>
+      <p:sp>
+        <p:nvSpPr>
+          <p:cNvPr id="11" name="Rounded Rectangle 10"/>
+          <p:cNvSpPr/>
+          <p:nvPr/>
+        </p:nvSpPr>
+        <p:spPr>
+          <a:xfrm>
+            <a:off x="533400" y="1828800"/>
+            <a:ext cx="5486400" cy="495300"/>
+          </a:xfrm>
+          <a:prstGeom prst="roundRect">
+            <a:avLst>
+              <a:gd name="adj" fmla="val 9000"/>
+            </a:avLst>
+          </a:prstGeom>
+          <a:solidFill>
+            <a:srgbClr val="E0600C"/>
+          </a:solidFill>
+          <a:ln>
+            <a:noFill/>
+          </a:ln>
+          <a:effectLst/>
+        </p:spPr>
+        <p:style>
+          <a:lnRef idx="1">
+            <a:schemeClr val="accent1"/>
+          </a:lnRef>
+          <a:fillRef idx="3">
+            <a:schemeClr val="accent1"/>
+          </a:fillRef>
+          <a:effectRef idx="2">
+            <a:schemeClr val="accent1"/>
+          </a:effectRef>
+          <a:fontRef idx="minor">
+            <a:schemeClr val="lt1"/>
+          </a:fontRef>
+        </p:style>
+        <p:txBody>
+          <a:bodyPr rtlCol="0" anchor="ctr"/>
+          <a:lstStyle/>
+          <a:p>
+            <a:pPr algn="ctr"/>
+          </a:p>
+        </p:txBody>
+      </p:sp>
+      <p:sp>
+        <p:nvSpPr>
+          <p:cNvPr id="12" name="Rectangle 11"/>
+          <p:cNvSpPr/>
+          <p:nvPr/>
+        </p:nvSpPr>
+        <p:spPr>
+          <a:xfrm>
+            <a:off x="533400" y="2095500"/>
+            <a:ext cx="5486400" cy="228600"/>
+          </a:xfrm>
+          <a:prstGeom prst="rect">
+            <a:avLst/>
+          </a:prstGeom>
+          <a:solidFill>
+            <a:srgbClr val="E0600C"/>
+          </a:solidFill>
+          <a:ln>
+            <a:noFill/>
+          </a:ln>
+          <a:effectLst/>
+        </p:spPr>
+        <p:style>
+          <a:lnRef idx="1">
+            <a:schemeClr val="accent1"/>
+          </a:lnRef>
+          <a:fillRef idx="3">
+            <a:schemeClr val="accent1"/>
+          </a:fillRef>
+          <a:effectRef idx="2">
+            <a:schemeClr val="accent1"/>
+          </a:effectRef>
+          <a:fontRef idx="minor">
+            <a:schemeClr val="lt1"/>
+          </a:fontRef>
+        </p:style>
+        <p:txBody>
+          <a:bodyPr rtlCol="0" anchor="ctr"/>
+          <a:lstStyle/>
+          <a:p>
+            <a:pPr algn="ctr"/>
+          </a:p>
+        </p:txBody>
+      </p:sp>
+      <p:sp>
+        <p:nvSpPr>
+          <p:cNvPr id="13" name="TextBox 12"/>
+          <p:cNvSpPr txBox="1"/>
+          <p:nvPr/>
+        </p:nvSpPr>
+        <p:spPr>
+          <a:xfrm>
+            <a:off x="685800" y="1828800"/>
+            <a:ext cx="5181600" cy="495300"/>
+          </a:xfrm>
+          <a:prstGeom prst="rect">
+            <a:avLst/>
+          </a:prstGeom>
+          <a:noFill/>
+          <a:ln>
+            <a:noFill/>
+          </a:ln>
+        </p:spPr>
+        <p:txBody>
+          <a:bodyPr wrap="square" anchor="ctr" lIns="40000" rIns="40000" tIns="12000" bIns="12000">
+            <a:spAutoFit/>
+          </a:bodyPr>
+          <a:lstStyle/>
+          <a:p>
+            <a:pPr algn="l"/>
+            <a:r>
+              <a:rPr sz="1150" b="1" i="0">
+                <a:solidFill>
+                  <a:srgbClr val="FFFFFF"/>
+                </a:solidFill>
+                <a:latin typeface="Calibri"/>
+              </a:rPr>
+              <a:t>VORMITTAG · Miteinander</a:t>
+            </a:r>
+          </a:p>
+        </p:txBody>
+      </p:sp>
+      <p:sp>
+        <p:nvSpPr>
+          <p:cNvPr id="14" name="TextBox 13"/>
+          <p:cNvSpPr txBox="1"/>
+          <p:nvPr/>
+        </p:nvSpPr>
+        <p:spPr>
+          <a:xfrm>
+            <a:off x="701040" y="2438400"/>
+            <a:ext cx="5181600" cy="3810000"/>
+          </a:xfrm>
+          <a:prstGeom prst="rect">
+            <a:avLst/>
+          </a:prstGeom>
+          <a:noFill/>
+          <a:ln>
+            <a:noFill/>
+          </a:ln>
+        </p:spPr>
+        <p:txBody>
+          <a:bodyPr wrap="square" anchor="t" lIns="40000" rIns="40000" tIns="12000" bIns="12000">
+            <a:spAutoFit/>
+          </a:bodyPr>
+          <a:lstStyle/>
+          <a:p>
+            <a:pPr algn="l">
+              <a:lnSpc>
+                <a:spcPct val="108000"/>
+              </a:lnSpc>
+              <a:spcAft>
+                <a:spcPts val="350"/>
+              </a:spcAft>
+            </a:pPr>
+            <a:r>
+              <a:rPr sz="1000" b="1" i="0">
+                <a:solidFill>
+                  <a:srgbClr val="E0600C"/>
+                </a:solidFill>
+                <a:latin typeface="Calibri"/>
+              </a:rPr>
+              <a:t>09:00   </a:t>
+            </a:r>
+            <a:r>
+              <a:rPr sz="1000" b="0" i="0">
+                <a:solidFill>
+                  <a:srgbClr val="1F2937"/>
+                </a:solidFill>
+                <a:latin typeface="Calibri"/>
+              </a:rPr>
+              <a:t>Ankommen &amp; Begrüßung (A. Passaro)</a:t>
+            </a:r>
+          </a:p>
+          <a:p>
+            <a:pPr algn="l">
+              <a:lnSpc>
+                <a:spcPct val="108000"/>
+              </a:lnSpc>
+              <a:spcAft>
+                <a:spcPts val="350"/>
+              </a:spcAft>
+            </a:pPr>
+            <a:r>
+              <a:rPr sz="1000" b="1" i="0">
+                <a:solidFill>
+                  <a:srgbClr val="E0600C"/>
+                </a:solidFill>
+                <a:latin typeface="Calibri"/>
+              </a:rPr>
+              <a:t>09:20   </a:t>
+            </a:r>
+            <a:r>
+              <a:rPr sz="1000" b="0" i="0">
+                <a:solidFill>
+                  <a:srgbClr val="1F2937"/>
+                </a:solidFill>
+                <a:latin typeface="Calibri"/>
+              </a:rPr>
+              <a:t>Warum wir hier sind — Zielbild der Abteilung</a:t>
+            </a:r>
+          </a:p>
+          <a:p>
+            <a:pPr algn="l">
+              <a:lnSpc>
+                <a:spcPct val="108000"/>
+              </a:lnSpc>
+              <a:spcAft>
+                <a:spcPts val="350"/>
+              </a:spcAft>
+            </a:pPr>
+            <a:r>
+              <a:rPr sz="1000" b="1" i="0">
+                <a:solidFill>
+                  <a:srgbClr val="E0600C"/>
+                </a:solidFill>
+                <a:latin typeface="Calibri"/>
+              </a:rPr>
+              <a:t>09:45   </a:t>
+            </a:r>
+            <a:r>
+              <a:rPr sz="1000" b="0" i="0">
+                <a:solidFill>
+                  <a:srgbClr val="1F2937"/>
+                </a:solidFill>
+                <a:latin typeface="Calibri"/>
+              </a:rPr>
+              <a:t>Kennenlernen: Vorstellung bewusst gemischt</a:t>
+            </a:r>
+          </a:p>
+          <a:p>
+            <a:pPr algn="l">
+              <a:lnSpc>
+                <a:spcPct val="108000"/>
+              </a:lnSpc>
+              <a:spcAft>
+                <a:spcPts val="350"/>
+              </a:spcAft>
+            </a:pPr>
+            <a:r>
+              <a:rPr sz="1000" b="1" i="0">
+                <a:solidFill>
+                  <a:srgbClr val="4B5563"/>
+                </a:solidFill>
+                <a:latin typeface="Calibri"/>
+              </a:rPr>
+              <a:t>10:30   </a:t>
+            </a:r>
+            <a:r>
+              <a:rPr sz="1000" b="0" i="1">
+                <a:solidFill>
+                  <a:srgbClr val="4B5563"/>
+                </a:solidFill>
+                <a:latin typeface="Calibri"/>
+              </a:rPr>
+              <a:t>Pause</a:t>
+            </a:r>
+          </a:p>
+          <a:p>
+            <a:pPr algn="l">
+              <a:lnSpc>
+                <a:spcPct val="108000"/>
+              </a:lnSpc>
+              <a:spcAft>
+                <a:spcPts val="350"/>
+              </a:spcAft>
+            </a:pPr>
+            <a:r>
+              <a:rPr sz="1000" b="1" i="0">
+                <a:solidFill>
+                  <a:srgbClr val="E0600C"/>
+                </a:solidFill>
+                <a:latin typeface="Calibri"/>
+              </a:rPr>
+              <a:t>10:45   </a:t>
+            </a:r>
+            <a:r>
+              <a:rPr sz="1000" b="0" i="0">
+                <a:solidFill>
+                  <a:srgbClr val="1F2937"/>
+                </a:solidFill>
+                <a:latin typeface="Calibri"/>
+              </a:rPr>
+              <a:t>Skills- &amp; Stärken-Landkarte</a:t>
+            </a:r>
+          </a:p>
+          <a:p>
+            <a:pPr algn="l">
+              <a:lnSpc>
+                <a:spcPct val="108000"/>
+              </a:lnSpc>
+              <a:spcAft>
+                <a:spcPts val="350"/>
+              </a:spcAft>
+            </a:pPr>
+            <a:r>
+              <a:rPr sz="1000" b="1" i="0">
+                <a:solidFill>
+                  <a:srgbClr val="E0600C"/>
+                </a:solidFill>
+                <a:latin typeface="Calibri"/>
+              </a:rPr>
+              <a:t>11:30   </a:t>
+            </a:r>
+            <a:r>
+              <a:rPr sz="1000" b="0" i="0">
+                <a:solidFill>
+                  <a:srgbClr val="1F2937"/>
+                </a:solidFill>
+                <a:latin typeface="Calibri"/>
+              </a:rPr>
+              <a:t>Erwartungen &amp; Werte → Team-Charter</a:t>
+            </a:r>
+          </a:p>
+          <a:p>
+            <a:pPr algn="l">
+              <a:lnSpc>
+                <a:spcPct val="108000"/>
+              </a:lnSpc>
+              <a:spcAft>
+                <a:spcPts val="350"/>
+              </a:spcAft>
+            </a:pPr>
+            <a:r>
+              <a:rPr sz="1000" b="1" i="0">
+                <a:solidFill>
+                  <a:srgbClr val="4B5563"/>
+                </a:solidFill>
+                <a:latin typeface="Calibri"/>
+              </a:rPr>
+              <a:t>12:30   </a:t>
+            </a:r>
+            <a:r>
+              <a:rPr sz="1000" b="0" i="1">
+                <a:solidFill>
+                  <a:srgbClr val="4B5563"/>
+                </a:solidFill>
+                <a:latin typeface="Calibri"/>
+              </a:rPr>
+              <a:t>Mittagspause</a:t>
+            </a:r>
+          </a:p>
+        </p:txBody>
+      </p:sp>
+      <p:sp>
+        <p:nvSpPr>
+          <p:cNvPr id="15" name="Rounded Rectangle 14"/>
+          <p:cNvSpPr/>
+          <p:nvPr/>
+        </p:nvSpPr>
+        <p:spPr>
+          <a:xfrm>
+            <a:off x="6172200" y="1828800"/>
+            <a:ext cx="5486400" cy="4495800"/>
+          </a:xfrm>
+          <a:prstGeom prst="roundRect">
+            <a:avLst>
+              <a:gd name="adj" fmla="val 9000"/>
+            </a:avLst>
+          </a:prstGeom>
+          <a:solidFill>
+            <a:srgbClr val="FFFFFF"/>
+          </a:solidFill>
+          <a:ln w="12700">
+            <a:solidFill>
+              <a:srgbClr val="D1D7DF"/>
+            </a:solidFill>
+          </a:ln>
+          <a:effectLst/>
+        </p:spPr>
+        <p:style>
+          <a:lnRef idx="1">
+            <a:schemeClr val="accent1"/>
+          </a:lnRef>
+          <a:fillRef idx="3">
+            <a:schemeClr val="accent1"/>
+          </a:fillRef>
+          <a:effectRef idx="2">
+            <a:schemeClr val="accent1"/>
+          </a:effectRef>
+          <a:fontRef idx="minor">
+            <a:schemeClr val="lt1"/>
+          </a:fontRef>
+        </p:style>
+        <p:txBody>
+          <a:bodyPr rtlCol="0" anchor="ctr"/>
+          <a:lstStyle/>
+          <a:p>
+            <a:pPr algn="ctr"/>
+          </a:p>
+        </p:txBody>
+      </p:sp>
+      <p:sp>
+        <p:nvSpPr>
+          <p:cNvPr id="16" name="Rounded Rectangle 15"/>
+          <p:cNvSpPr/>
+          <p:nvPr/>
+        </p:nvSpPr>
+        <p:spPr>
+          <a:xfrm>
+            <a:off x="6172200" y="1828800"/>
+            <a:ext cx="5486400" cy="495300"/>
+          </a:xfrm>
+          <a:prstGeom prst="roundRect">
+            <a:avLst>
+              <a:gd name="adj" fmla="val 9000"/>
+            </a:avLst>
+          </a:prstGeom>
+          <a:solidFill>
+            <a:srgbClr val="2E6CB0"/>
+          </a:solidFill>
+          <a:ln>
+            <a:noFill/>
+          </a:ln>
+          <a:effectLst/>
+        </p:spPr>
+        <p:style>
+          <a:lnRef idx="1">
+            <a:schemeClr val="accent1"/>
+          </a:lnRef>
+          <a:fillRef idx="3">
+            <a:schemeClr val="accent1"/>
+          </a:fillRef>
+          <a:effectRef idx="2">
+            <a:schemeClr val="accent1"/>
+          </a:effectRef>
+          <a:fontRef idx="minor">
+            <a:schemeClr val="lt1"/>
+          </a:fontRef>
+        </p:style>
+        <p:txBody>
+          <a:bodyPr rtlCol="0" anchor="ctr"/>
+          <a:lstStyle/>
+          <a:p>
+            <a:pPr algn="ctr"/>
+          </a:p>
+        </p:txBody>
+      </p:sp>
+      <p:sp>
+        <p:nvSpPr>
+          <p:cNvPr id="17" name="Rectangle 16"/>
+          <p:cNvSpPr/>
+          <p:nvPr/>
+        </p:nvSpPr>
+        <p:spPr>
+          <a:xfrm>
+            <a:off x="6172200" y="2095500"/>
+            <a:ext cx="5486400" cy="228600"/>
+          </a:xfrm>
+          <a:prstGeom prst="rect">
+            <a:avLst/>
+          </a:prstGeom>
+          <a:solidFill>
+            <a:srgbClr val="2E6CB0"/>
+          </a:solidFill>
+          <a:ln>
+            <a:noFill/>
+          </a:ln>
+          <a:effectLst/>
+        </p:spPr>
+        <p:style>
+          <a:lnRef idx="1">
+            <a:schemeClr val="accent1"/>
+          </a:lnRef>
+          <a:fillRef idx="3">
+            <a:schemeClr val="accent1"/>
+          </a:fillRef>
+          <a:effectRef idx="2">
+            <a:schemeClr val="accent1"/>
+          </a:effectRef>
+          <a:fontRef idx="minor">
+            <a:schemeClr val="lt1"/>
+          </a:fontRef>
+        </p:style>
+        <p:txBody>
+          <a:bodyPr rtlCol="0" anchor="ctr"/>
+          <a:lstStyle/>
+          <a:p>
+            <a:pPr algn="ctr"/>
+          </a:p>
+        </p:txBody>
+      </p:sp>
+      <p:sp>
+        <p:nvSpPr>
+          <p:cNvPr id="18" name="TextBox 17"/>
+          <p:cNvSpPr txBox="1"/>
+          <p:nvPr/>
+        </p:nvSpPr>
+        <p:spPr>
+          <a:xfrm>
+            <a:off x="6324600" y="1828800"/>
+            <a:ext cx="5181600" cy="495300"/>
+          </a:xfrm>
+          <a:prstGeom prst="rect">
+            <a:avLst/>
+          </a:prstGeom>
+          <a:noFill/>
+          <a:ln>
+            <a:noFill/>
+          </a:ln>
+        </p:spPr>
+        <p:txBody>
+          <a:bodyPr wrap="square" anchor="ctr" lIns="40000" rIns="40000" tIns="12000" bIns="12000">
+            <a:spAutoFit/>
+          </a:bodyPr>
+          <a:lstStyle/>
+          <a:p>
+            <a:pPr algn="l"/>
+            <a:r>
+              <a:rPr sz="1150" b="1" i="0">
+                <a:solidFill>
+                  <a:srgbClr val="FFFFFF"/>
+                </a:solidFill>
+                <a:latin typeface="Calibri"/>
+              </a:rPr>
+              <a:t>NACHMITTAG · Auftrag &amp; Scope</a:t>
+            </a:r>
+          </a:p>
+        </p:txBody>
+      </p:sp>
+      <p:sp>
+        <p:nvSpPr>
+          <p:cNvPr id="19" name="TextBox 18"/>
+          <p:cNvSpPr txBox="1"/>
+          <p:nvPr/>
+        </p:nvSpPr>
+        <p:spPr>
+          <a:xfrm>
+            <a:off x="6339840" y="2438400"/>
+            <a:ext cx="5181600" cy="3810000"/>
+          </a:xfrm>
+          <a:prstGeom prst="rect">
+            <a:avLst/>
+          </a:prstGeom>
+          <a:noFill/>
+          <a:ln>
+            <a:noFill/>
+          </a:ln>
+        </p:spPr>
+        <p:txBody>
+          <a:bodyPr wrap="square" anchor="t" lIns="40000" rIns="40000" tIns="12000" bIns="12000">
+            <a:spAutoFit/>
+          </a:bodyPr>
+          <a:lstStyle/>
+          <a:p>
+            <a:pPr algn="l">
+              <a:lnSpc>
+                <a:spcPct val="108000"/>
+              </a:lnSpc>
+              <a:spcAft>
+                <a:spcPts val="350"/>
+              </a:spcAft>
+            </a:pPr>
+            <a:r>
+              <a:rPr sz="1000" b="1" i="0">
+                <a:solidFill>
+                  <a:srgbClr val="2E6CB0"/>
+                </a:solidFill>
+                <a:latin typeface="Calibri"/>
+              </a:rPr>
+              <a:t>13:30   </a:t>
+            </a:r>
+            <a:r>
+              <a:rPr sz="1000" b="0" i="0">
+                <a:solidFill>
+                  <a:srgbClr val="1F2937"/>
+                </a:solidFill>
+                <a:latin typeface="Calibri"/>
+              </a:rPr>
+              <a:t>Unsere Mission &amp; sechs Leitmotive</a:t>
+            </a:r>
+          </a:p>
+          <a:p>
+            <a:pPr algn="l">
+              <a:lnSpc>
+                <a:spcPct val="108000"/>
+              </a:lnSpc>
+              <a:spcAft>
+                <a:spcPts val="350"/>
+              </a:spcAft>
+            </a:pPr>
+            <a:r>
+              <a:rPr sz="1000" b="1" i="0">
+                <a:solidFill>
+                  <a:srgbClr val="2E6CB0"/>
+                </a:solidFill>
+                <a:latin typeface="Calibri"/>
+              </a:rPr>
+              <a:t>14:00   </a:t>
+            </a:r>
+            <a:r>
+              <a:rPr sz="1000" b="0" i="0">
+                <a:solidFill>
+                  <a:srgbClr val="1F2937"/>
+                </a:solidFill>
+                <a:latin typeface="Calibri"/>
+              </a:rPr>
+              <a:t>Scope je Säule: In/Out (3 Teams parallel)</a:t>
+            </a:r>
+          </a:p>
+          <a:p>
+            <a:pPr algn="l">
+              <a:lnSpc>
+                <a:spcPct val="108000"/>
+              </a:lnSpc>
+              <a:spcAft>
+                <a:spcPts val="350"/>
+              </a:spcAft>
+            </a:pPr>
+            <a:r>
+              <a:rPr sz="1000" b="1" i="0">
+                <a:solidFill>
+                  <a:srgbClr val="2E6CB0"/>
+                </a:solidFill>
+                <a:latin typeface="Calibri"/>
+              </a:rPr>
+              <a:t>15:00   </a:t>
+            </a:r>
+            <a:r>
+              <a:rPr sz="1000" b="0" i="0">
+                <a:solidFill>
+                  <a:srgbClr val="1F2937"/>
+                </a:solidFill>
+                <a:latin typeface="Calibri"/>
+              </a:rPr>
+              <a:t>Schnittstellen: intern &amp; nach außen</a:t>
+            </a:r>
+          </a:p>
+          <a:p>
+            <a:pPr algn="l">
+              <a:lnSpc>
+                <a:spcPct val="108000"/>
+              </a:lnSpc>
+              <a:spcAft>
+                <a:spcPts val="350"/>
+              </a:spcAft>
+            </a:pPr>
+            <a:r>
+              <a:rPr sz="1000" b="1" i="0">
+                <a:solidFill>
+                  <a:srgbClr val="4B5563"/>
+                </a:solidFill>
+                <a:latin typeface="Calibri"/>
+              </a:rPr>
+              <a:t>15:30   </a:t>
+            </a:r>
+            <a:r>
+              <a:rPr sz="1000" b="0" i="1">
+                <a:solidFill>
+                  <a:srgbClr val="4B5563"/>
+                </a:solidFill>
+                <a:latin typeface="Calibri"/>
+              </a:rPr>
+              <a:t>Pause</a:t>
+            </a:r>
+          </a:p>
+          <a:p>
+            <a:pPr algn="l">
+              <a:lnSpc>
+                <a:spcPct val="108000"/>
+              </a:lnSpc>
+              <a:spcAft>
+                <a:spcPts val="350"/>
+              </a:spcAft>
+            </a:pPr>
+            <a:r>
+              <a:rPr sz="1000" b="1" i="0">
+                <a:solidFill>
+                  <a:srgbClr val="2E6CB0"/>
+                </a:solidFill>
+                <a:latin typeface="Calibri"/>
+              </a:rPr>
+              <a:t>15:45   </a:t>
+            </a:r>
+            <a:r>
+              <a:rPr sz="1000" b="0" i="0">
+                <a:solidFill>
+                  <a:srgbClr val="1F2937"/>
+                </a:solidFill>
+                <a:latin typeface="Calibri"/>
+              </a:rPr>
+              <a:t>Scope-Landkarte konsolidieren</a:t>
+            </a:r>
+          </a:p>
+          <a:p>
+            <a:pPr algn="l">
+              <a:lnSpc>
+                <a:spcPct val="108000"/>
+              </a:lnSpc>
+              <a:spcAft>
+                <a:spcPts val="350"/>
+              </a:spcAft>
+            </a:pPr>
+            <a:r>
+              <a:rPr sz="1000" b="1" i="0">
+                <a:solidFill>
+                  <a:srgbClr val="2E6CB0"/>
+                </a:solidFill>
+                <a:latin typeface="Calibri"/>
+              </a:rPr>
+              <a:t>16:15   </a:t>
+            </a:r>
+            <a:r>
+              <a:rPr sz="1000" b="0" i="0">
+                <a:solidFill>
+                  <a:srgbClr val="1F2937"/>
+                </a:solidFill>
+                <a:latin typeface="Calibri"/>
+              </a:rPr>
+              <a:t>Zusammenarbeit &amp; Rituale vereinbaren</a:t>
+            </a:r>
+          </a:p>
+          <a:p>
+            <a:pPr algn="l">
+              <a:lnSpc>
+                <a:spcPct val="108000"/>
+              </a:lnSpc>
+              <a:spcAft>
+                <a:spcPts val="350"/>
+              </a:spcAft>
+            </a:pPr>
+            <a:r>
+              <a:rPr sz="1000" b="1" i="0">
+                <a:solidFill>
+                  <a:srgbClr val="2E6CB0"/>
+                </a:solidFill>
+                <a:latin typeface="Calibri"/>
+              </a:rPr>
+              <a:t>16:45   </a:t>
+            </a:r>
+            <a:r>
+              <a:rPr sz="1000" b="0" i="0">
+                <a:solidFill>
+                  <a:srgbClr val="1F2937"/>
+                </a:solidFill>
+                <a:latin typeface="Calibri"/>
+              </a:rPr>
+              <a:t>Commitments &amp; nächste Schritte</a:t>
+            </a:r>
+          </a:p>
+          <a:p>
+            <a:pPr algn="l">
+              <a:lnSpc>
+                <a:spcPct val="108000"/>
+              </a:lnSpc>
+              <a:spcAft>
+                <a:spcPts val="350"/>
+              </a:spcAft>
+            </a:pPr>
+            <a:r>
+              <a:rPr sz="1000" b="1" i="0">
+                <a:solidFill>
+                  <a:srgbClr val="2E6CB0"/>
+                </a:solidFill>
+                <a:latin typeface="Calibri"/>
+              </a:rPr>
+              <a:t>17:00   </a:t>
+            </a:r>
+            <a:r>
+              <a:rPr sz="1000" b="0" i="0">
+                <a:solidFill>
+                  <a:srgbClr val="1F2937"/>
+                </a:solidFill>
+                <a:latin typeface="Calibri"/>
+              </a:rPr>
+              <a:t>Abschluss &amp; gemeinsamer Ausklang</a:t>
             </a:r>
           </a:p>
         </p:txBody>

</xml_diff>